<commit_message>
Architecture PPT: Running on Tencent Cloud slide (ADP settings, knowledge base, publish history, Lighthouse); Miora video creatives
</commit_message>
<xml_diff>
--- a/submission/architecture/laile-architecture.pptx
+++ b/submission/architecture/laile-architecture.pptx
@@ -11,9 +11,10 @@
     <p:sldId id="259" r:id="rId5"/>
     <p:sldId id="260" r:id="rId6"/>
     <p:sldId id="261" r:id="rId7"/>
+    <p:sldId id="262" r:id="rId8"/>
   </p:sldIdLst>
   <p:notesMasterIdLst>
-    <p:notesMasterId r:id="rId8"/>
+    <p:notesMasterId r:id="rId9"/>
   </p:notesMasterIdLst>
   <p:sldSz cx="12192000" cy="6858000"/>
   <p:notesSz cx="6858000" cy="12192000"/>
@@ -112,22 +113,23 @@
   <p:extLst>
     <p:ext uri="{521415D9-36F7-43E2-AB2F-B90AF26B5E84}">
       <p14:sectionLst xmlns:p14="http://schemas.microsoft.com/office/powerpoint/2010/main">
-        <p14:section name="Overview" id="{027348c8-74c0-805f-694c-7e3bcd8e1ff4}">
+        <p14:section name="Overview" id="{26ef719b-610b-2fe8-267f-e4ff9f78ce21}">
           <p14:sldIdLst>
             <p14:sldId id="256"/>
           </p14:sldIdLst>
         </p14:section>
-        <p14:section name="Architecture" id="{a3ecb8bd-dde3-6d93-769a-6441cbc99d8c}">
+        <p14:section name="Architecture" id="{54467dff-0476-f395-72da-8707821fee14}">
           <p14:sldIdLst>
             <p14:sldId id="257"/>
             <p14:sldId id="258"/>
             <p14:sldId id="259"/>
+            <p14:sldId id="260"/>
           </p14:sldIdLst>
         </p14:section>
-        <p14:section name="Build" id="{34ea018d-3dba-107b-81dc-cbdcc92470d3}">
+        <p14:section name="Build" id="{b3131de2-1aa4-2433-5b43-3d0acb3c3bd3}">
           <p14:sldIdLst>
-            <p14:sldId id="260"/>
             <p14:sldId id="261"/>
+            <p14:sldId id="262"/>
           </p14:sldIdLst>
         </p14:section>
       </p14:sectionLst>
@@ -710,7 +712,7 @@
           <a:p>
             <a:r>
               <a:rPr lang="en-US" dirty="0"/>
-              <a:t>The model talks; code decides. Every number a physio sees comes from tested code.</a:t>
+              <a:t>Console screenshots, 15 Oct 2026. The ADP app is named Laile; the agent inside it is Lele.</a:t>
             </a:r>
             <a:endParaRPr lang="en-US" dirty="0"/>
           </a:p>
@@ -798,7 +800,7 @@
           <a:p>
             <a:r>
               <a:rPr lang="en-US" dirty="0"/>
-              <a:t>All three go to the same ADP agent; the server prefixes PLAN REQUEST or CLINICIAN BRIEF and the agent prompt has a section for each mode.</a:t>
+              <a:t>The model talks; code decides. Every number a physio sees comes from tested code.</a:t>
             </a:r>
             <a:endParaRPr lang="en-US" dirty="0"/>
           </a:p>
@@ -886,7 +888,7 @@
           <a:p>
             <a:r>
               <a:rPr lang="en-US" dirty="0"/>
-              <a:t>One language for the domain logic; the phone and the server run the same LaileCore package.</a:t>
+              <a:t>All three go to the same ADP agent; the server prefixes PLAN REQUEST or CLINICIAN BRIEF and the agent prompt has a section for each mode.</a:t>
             </a:r>
             <a:endParaRPr lang="en-US" dirty="0"/>
           </a:p>
@@ -974,7 +976,7 @@
           <a:p>
             <a:r>
               <a:rPr lang="en-US" dirty="0"/>
-              <a:t>Each choice trades something; these are the ones that shaped Laile.</a:t>
+              <a:t>One language for the domain logic; the phone and the server run the same LaileCore package.</a:t>
             </a:r>
             <a:endParaRPr lang="en-US" dirty="0"/>
           </a:p>
@@ -998,6 +1000,94 @@
             <a:fld id="{F7021451-1387-4CA6-816F-3879F97B5CBC}" type="slidenum">
               <a:rPr lang="en-US"/>
               <a:t>6</a:t>
+            </a:fld>
+            <a:endParaRPr lang="en-US"/>
+          </a:p>
+        </p:txBody>
+      </p:sp>
+    </p:spTree>
+    <p:extLst>
+      <p:ext uri="{BB962C8B-B14F-4D97-AF65-F5344CB8AC3E}">
+        <p14:creationId xmlns:p14="http://schemas.microsoft.com/office/powerpoint/2010/main" val="1024086991"/>
+      </p:ext>
+    </p:extLst>
+  </p:cSld>
+  <p:clrMapOvr>
+    <a:masterClrMapping/>
+  </p:clrMapOvr>
+</p:notes>
+</file>
+
+<file path=ppt/notesSlides/notesSlide7.xml><?xml version="1.0" encoding="utf-8"?>
+<p:notes xmlns:a="http://schemas.openxmlformats.org/drawingml/2006/main" xmlns:r="http://schemas.openxmlformats.org/officeDocument/2006/relationships" xmlns:p="http://schemas.openxmlformats.org/presentationml/2006/main">
+  <p:cSld>
+    <p:spTree>
+      <p:nvGrpSpPr>
+        <p:cNvPr id="1" name=""/>
+        <p:cNvGrpSpPr/>
+        <p:nvPr/>
+      </p:nvGrpSpPr>
+      <p:grpSpPr>
+        <a:xfrm>
+          <a:off x="0" y="0"/>
+          <a:ext cx="0" cy="0"/>
+          <a:chOff x="0" y="0"/>
+          <a:chExt cx="0" cy="0"/>
+        </a:xfrm>
+      </p:grpSpPr>
+      <p:sp>
+        <p:nvSpPr>
+          <p:cNvPr id="2" name="Slide Image Placeholder 1"/>
+          <p:cNvSpPr>
+            <a:spLocks noGrp="1" noRot="1" noChangeAspect="1"/>
+          </p:cNvSpPr>
+          <p:nvPr>
+            <p:ph type="sldImg"/>
+          </p:nvPr>
+        </p:nvSpPr>
+        <p:spPr/>
+      </p:sp>
+      <p:sp>
+        <p:nvSpPr>
+          <p:cNvPr id="3" name="Notes Placeholder 2"/>
+          <p:cNvSpPr>
+            <a:spLocks noGrp="1"/>
+          </p:cNvSpPr>
+          <p:nvPr>
+            <p:ph type="body" idx="1"/>
+          </p:nvPr>
+        </p:nvSpPr>
+        <p:spPr/>
+        <p:txBody>
+          <a:bodyPr/>
+          <a:lstStyle/>
+          <a:p>
+            <a:r>
+              <a:rPr lang="en-US" dirty="0"/>
+              <a:t>Each choice trades something; these are the ones that shaped Laile.</a:t>
+            </a:r>
+            <a:endParaRPr lang="en-US" dirty="0"/>
+          </a:p>
+        </p:txBody>
+      </p:sp>
+      <p:sp>
+        <p:nvSpPr>
+          <p:cNvPr id="4" name="Slide Number Placeholder 3"/>
+          <p:cNvSpPr>
+            <a:spLocks noGrp="1"/>
+          </p:cNvSpPr>
+          <p:nvPr>
+            <p:ph type="sldNum" sz="quarter" idx="10"/>
+          </p:nvPr>
+        </p:nvSpPr>
+        <p:spPr/>
+        <p:txBody>
+          <a:bodyPr/>
+          <a:lstStyle/>
+          <a:p>
+            <a:fld id="{F7021451-1387-4CA6-816F-3879F97B5CBC}" type="slidenum">
+              <a:rPr lang="en-US"/>
+              <a:t>7</a:t>
             </a:fld>
             <a:endParaRPr lang="en-US"/>
           </a:p>
@@ -2015,6 +2105,404 @@
                   <a:schemeClr val="tx1"/>
                 </a:solidFill>
               </a:rPr>
+              <a:t>Running on Tencent Cloud</a:t>
+            </a:r>
+            <a:endParaRPr lang="en-US" sz="3200" dirty="0"/>
+          </a:p>
+        </p:txBody>
+      </p:sp>
+      <p:pic>
+        <p:nvPicPr>
+          <p:cNvPr id="3" name="ADP settings" descr="Lele's ADP settings: models, role prompt and welcome message">    </p:cNvPr>
+          <p:cNvPicPr>
+            <a:picLocks noChangeAspect="1"/>
+          </p:cNvPicPr>
+          <p:nvPr/>
+        </p:nvPicPr>
+        <p:blipFill>
+          <a:blip r:embed="rId1"/>
+          <a:stretch>
+            <a:fillRect/>
+          </a:stretch>
+        </p:blipFill>
+        <p:spPr>
+          <a:xfrm>
+            <a:off x="548640" y="1234440"/>
+            <a:ext cx="2560320" cy="4449660"/>
+          </a:xfrm>
+          <a:prstGeom prst="rect">
+            <a:avLst/>
+          </a:prstGeom>
+        </p:spPr>
+      </p:pic>
+      <p:sp>
+        <p:nvSpPr>
+          <p:cNvPr id="4" name="Text 1"/>
+          <p:cNvSpPr txBox="1"/>
+          <p:nvPr/>
+        </p:nvSpPr>
+        <p:spPr>
+          <a:xfrm>
+            <a:off x="548640" y="5760720"/>
+            <a:ext cx="2743200" cy="274320"/>
+          </a:xfrm>
+          <a:prstGeom prst="rect">
+            <a:avLst/>
+          </a:prstGeom>
+          <a:noFill/>
+          <a:ln/>
+        </p:spPr>
+        <p:txBody>
+          <a:bodyPr wrap="square" lIns="0" tIns="0" rIns="0" bIns="0" rtlCol="0" anchor="ctr"/>
+          <a:lstStyle/>
+          <a:p>
+            <a:pPr indent="0" marL="0">
+              <a:buNone/>
+            </a:pPr>
+            <a:r>
+              <a:rPr lang="en-US" sz="1100" dirty="0">
+                <a:solidFill>
+                  <a:schemeClr val="accent4"/>
+                </a:solidFill>
+              </a:rPr>
+              <a:t>ADP: Lele's models, role prompt and welcome</a:t>
+            </a:r>
+            <a:endParaRPr lang="en-US" sz="1100" dirty="0"/>
+          </a:p>
+        </p:txBody>
+      </p:sp>
+      <p:pic>
+        <p:nvPicPr>
+          <p:cNvPr id="5" name="ADP knowledge base" descr="ADP knowledge base: the 12 Laile documents, older versions switched off">    </p:cNvPr>
+          <p:cNvPicPr>
+            <a:picLocks noChangeAspect="1"/>
+          </p:cNvPicPr>
+          <p:nvPr/>
+        </p:nvPicPr>
+        <p:blipFill>
+          <a:blip r:embed="rId2"/>
+          <a:stretch>
+            <a:fillRect/>
+          </a:stretch>
+        </p:blipFill>
+        <p:spPr>
+          <a:xfrm>
+            <a:off x="3429000" y="1234440"/>
+            <a:ext cx="4846320" cy="2362581"/>
+          </a:xfrm>
+          <a:prstGeom prst="rect">
+            <a:avLst/>
+          </a:prstGeom>
+        </p:spPr>
+      </p:pic>
+      <p:sp>
+        <p:nvSpPr>
+          <p:cNvPr id="6" name="Text 2"/>
+          <p:cNvSpPr txBox="1"/>
+          <p:nvPr/>
+        </p:nvSpPr>
+        <p:spPr>
+          <a:xfrm>
+            <a:off x="3429000" y="3670173"/>
+            <a:ext cx="4846320" cy="274320"/>
+          </a:xfrm>
+          <a:prstGeom prst="rect">
+            <a:avLst/>
+          </a:prstGeom>
+          <a:noFill/>
+          <a:ln/>
+        </p:spPr>
+        <p:txBody>
+          <a:bodyPr wrap="square" lIns="0" tIns="0" rIns="0" bIns="0" rtlCol="0" anchor="ctr"/>
+          <a:lstStyle/>
+          <a:p>
+            <a:pPr indent="0" marL="0">
+              <a:buNone/>
+            </a:pPr>
+            <a:r>
+              <a:rPr lang="en-US" sz="1100" dirty="0">
+                <a:solidFill>
+                  <a:schemeClr val="accent4"/>
+                </a:solidFill>
+              </a:rPr>
+              <a:t>ADP knowledge base: 12 active documents in two categories</a:t>
+            </a:r>
+            <a:endParaRPr lang="en-US" sz="1100" dirty="0"/>
+          </a:p>
+        </p:txBody>
+      </p:sp>
+      <p:pic>
+        <p:nvPicPr>
+          <p:cNvPr id="7" name="Lighthouse server" descr="Lighthouse: the laile server in Singapore, running">    </p:cNvPr>
+          <p:cNvPicPr>
+            <a:picLocks noChangeAspect="1"/>
+          </p:cNvPicPr>
+          <p:nvPr/>
+        </p:nvPicPr>
+        <p:blipFill>
+          <a:blip r:embed="rId3"/>
+          <a:stretch>
+            <a:fillRect/>
+          </a:stretch>
+        </p:blipFill>
+        <p:spPr>
+          <a:xfrm>
+            <a:off x="8549640" y="1234440"/>
+            <a:ext cx="3063240" cy="1980543"/>
+          </a:xfrm>
+          <a:prstGeom prst="rect">
+            <a:avLst/>
+          </a:prstGeom>
+        </p:spPr>
+      </p:pic>
+      <p:sp>
+        <p:nvSpPr>
+          <p:cNvPr id="8" name="Text 3"/>
+          <p:cNvSpPr txBox="1"/>
+          <p:nvPr/>
+        </p:nvSpPr>
+        <p:spPr>
+          <a:xfrm>
+            <a:off x="8549640" y="3288135"/>
+            <a:ext cx="3063240" cy="274320"/>
+          </a:xfrm>
+          <a:prstGeom prst="rect">
+            <a:avLst/>
+          </a:prstGeom>
+          <a:noFill/>
+          <a:ln/>
+        </p:spPr>
+        <p:txBody>
+          <a:bodyPr wrap="square" lIns="0" tIns="0" rIns="0" bIns="0" rtlCol="0" anchor="ctr"/>
+          <a:lstStyle/>
+          <a:p>
+            <a:pPr indent="0" marL="0">
+              <a:buNone/>
+            </a:pPr>
+            <a:r>
+              <a:rPr lang="en-US" sz="1100" dirty="0">
+                <a:solidFill>
+                  <a:schemeClr val="accent4"/>
+                </a:solidFill>
+              </a:rPr>
+              <a:t>Lighthouse: the Laile server, Singapore</a:t>
+            </a:r>
+            <a:endParaRPr lang="en-US" sz="1100" dirty="0"/>
+          </a:p>
+        </p:txBody>
+      </p:sp>
+      <p:sp>
+        <p:nvSpPr>
+          <p:cNvPr id="9" name="Text 4"/>
+          <p:cNvSpPr txBox="1"/>
+          <p:nvPr/>
+        </p:nvSpPr>
+        <p:spPr>
+          <a:xfrm>
+            <a:off x="8549640" y="4160520"/>
+            <a:ext cx="3063240" cy="822960"/>
+          </a:xfrm>
+          <a:prstGeom prst="rect">
+            <a:avLst/>
+          </a:prstGeom>
+          <a:noFill/>
+          <a:ln/>
+        </p:spPr>
+        <p:txBody>
+          <a:bodyPr wrap="square" lIns="0" tIns="0" rIns="0" bIns="0" rtlCol="0" anchor="t"/>
+          <a:lstStyle/>
+          <a:p>
+            <a:pPr indent="0" marL="0">
+              <a:buNone/>
+            </a:pPr>
+            <a:r>
+              <a:rPr lang="en-US" sz="1300" b="1" dirty="0">
+                <a:solidFill>
+                  <a:schemeClr val="accent1"/>
+                </a:solidFill>
+              </a:rPr>
+              <a:t>Try Lele directly on ADP</a:t>
+            </a:r>
+            <a:endParaRPr lang="en-US" sz="1300" dirty="0"/>
+          </a:p>
+          <a:p>
+            <a:pPr indent="0" marL="0">
+              <a:buNone/>
+            </a:pPr>
+            <a:r>
+              <a:rPr lang="en-US" sz="1300" dirty="0">
+                <a:solidFill>
+                  <a:schemeClr val="tx1"/>
+                </a:solidFill>
+              </a:rPr>
+              <a:t>adp.tencentcloud.com/webim_exp/#/chat/nZbZZz</a:t>
+            </a:r>
+            <a:endParaRPr lang="en-US" sz="1300" dirty="0"/>
+          </a:p>
+        </p:txBody>
+      </p:sp>
+      <p:pic>
+        <p:nvPicPr>
+          <p:cNvPr id="10" name="ADP publish history" descr="ADP publish history: three published versions of Lele">    </p:cNvPr>
+          <p:cNvPicPr>
+            <a:picLocks noChangeAspect="1"/>
+          </p:cNvPicPr>
+          <p:nvPr/>
+        </p:nvPicPr>
+        <p:blipFill>
+          <a:blip r:embed="rId4"/>
+          <a:stretch>
+            <a:fillRect/>
+          </a:stretch>
+        </p:blipFill>
+        <p:spPr>
+          <a:xfrm>
+            <a:off x="3429000" y="4160520"/>
+            <a:ext cx="4846320" cy="1296391"/>
+          </a:xfrm>
+          <a:prstGeom prst="rect">
+            <a:avLst/>
+          </a:prstGeom>
+        </p:spPr>
+      </p:pic>
+      <p:sp>
+        <p:nvSpPr>
+          <p:cNvPr id="11" name="Text 5"/>
+          <p:cNvSpPr txBox="1"/>
+          <p:nvPr/>
+        </p:nvSpPr>
+        <p:spPr>
+          <a:xfrm>
+            <a:off x="3429000" y="5530063"/>
+            <a:ext cx="4846320" cy="274320"/>
+          </a:xfrm>
+          <a:prstGeom prst="rect">
+            <a:avLst/>
+          </a:prstGeom>
+          <a:noFill/>
+          <a:ln/>
+        </p:spPr>
+        <p:txBody>
+          <a:bodyPr wrap="square" lIns="0" tIns="0" rIns="0" bIns="0" rtlCol="0" anchor="ctr"/>
+          <a:lstStyle/>
+          <a:p>
+            <a:pPr indent="0" marL="0">
+              <a:buNone/>
+            </a:pPr>
+            <a:r>
+              <a:rPr lang="en-US" sz="1100" dirty="0">
+                <a:solidFill>
+                  <a:schemeClr val="accent4"/>
+                </a:solidFill>
+              </a:rPr>
+              <a:t>ADP publish history: three published versions, latest 12 Oct</a:t>
+            </a:r>
+            <a:endParaRPr lang="en-US" sz="1100" dirty="0"/>
+          </a:p>
+        </p:txBody>
+      </p:sp>
+      <p:sp>
+        <p:nvSpPr>
+          <p:cNvPr id="25" name="Slide Number Placeholder 0"/>
+          <p:cNvSpPr>
+            <a:spLocks noGrp="1"/>
+          </p:cNvSpPr>
+          <p:nvPr>
+            <p:ph type="sldNum" sz="quarter" idx="4294967295"/>
+          </p:nvPr>
+        </p:nvSpPr>
+        <p:spPr>
+          <a:xfrm>
+            <a:off x="11155680" y="6400800"/>
+            <a:ext cx="457200" cy="274320"/>
+          </a:xfrm>
+          <a:prstGeom prst="rect">
+            <a:avLst/>
+          </a:prstGeom>
+          <a:extLst>
+            <a:ext uri="{C572A759-6A51-4108-AA02-DFA0A04FC94B}">
+              <ma14:wrappingTextBoxFlag xmlns:ma14="http://schemas.microsoft.com/office/mac/drawingml/2011/main" val="0"/>
+            </a:ext>
+          </a:extLst>
+        </p:spPr>
+        <p:txBody>
+          <a:bodyPr/>
+          <a:lstStyle>
+            <a:lvl1pPr>
+              <a:defRPr sz="1000">
+                <a:solidFill>
+                  <a:schemeClr val="accent4"/>
+                </a:solidFill>
+              </a:defRPr>
+            </a:lvl1pPr>
+          </a:lstStyle>
+          <a:p>
+            <a:pPr algn="r"/>
+            <a:fld id="{F7021451-1387-4CA6-816F-3879F97B5CBC}" type="slidenum">
+              <a:rPr b="0" lang="en-US"/>
+              <a:t>3</a:t>
+            </a:fld>
+            <a:endParaRPr lang="en-US"/>
+          </a:p>
+        </p:txBody>
+      </p:sp>
+    </p:spTree>
+  </p:cSld>
+  <p:clrMapOvr>
+    <a:masterClrMapping/>
+  </p:clrMapOvr>
+</p:sld>
+</file>
+
+<file path=ppt/slides/slide4.xml><?xml version="1.0" encoding="utf-8"?>
+<p:sld xmlns:a="http://schemas.openxmlformats.org/drawingml/2006/main" xmlns:r="http://schemas.openxmlformats.org/officeDocument/2006/relationships" xmlns:p="http://schemas.openxmlformats.org/presentationml/2006/main">
+  <p:cSld name="Slide 4">
+    <p:spTree>
+      <p:nvGrpSpPr>
+        <p:cNvPr id="1" name=""/>
+        <p:cNvGrpSpPr/>
+        <p:nvPr/>
+      </p:nvGrpSpPr>
+      <p:grpSpPr>
+        <a:xfrm>
+          <a:off x="0" y="0"/>
+          <a:ext cx="0" cy="0"/>
+          <a:chOff x="0" y="0"/>
+          <a:chExt cx="0" cy="0"/>
+        </a:xfrm>
+      </p:grpSpPr>
+      <p:sp>
+        <p:nvSpPr>
+          <p:cNvPr id="2" name="Text 0"/>
+          <p:cNvSpPr/>
+          <p:nvPr>
+            <p:ph idx="100" type="title" hasCustomPrompt="1"/>
+          </p:nvPr>
+        </p:nvSpPr>
+        <p:spPr>
+          <a:xfrm>
+            <a:off x="548640" y="320040"/>
+            <a:ext cx="11064240" cy="731520"/>
+          </a:xfrm>
+          <a:prstGeom prst="rect">
+            <a:avLst/>
+          </a:prstGeom>
+          <a:noFill/>
+          <a:ln/>
+        </p:spPr>
+        <p:txBody>
+          <a:bodyPr wrap="square" lIns="0" tIns="0" rIns="0" bIns="0" rtlCol="0" anchor="ctr"/>
+          <a:lstStyle/>
+          <a:p>
+            <a:pPr algn="l" indent="0" marL="0">
+              <a:buNone/>
+            </a:pPr>
+            <a:r>
+              <a:rPr lang="en-US" sz="3200" b="1" dirty="0">
+                <a:solidFill>
+                  <a:schemeClr val="tx1"/>
+                </a:solidFill>
+              </a:rPr>
               <a:t>How the AI is used, and kept safe</a:t>
             </a:r>
             <a:endParaRPr lang="en-US" sz="3200" dirty="0"/>
@@ -2023,7 +2511,7 @@
       </p:sp>
       <p:graphicFrame>
         <p:nvGraphicFramePr>
-          <p:cNvPr id="4" name="AI and safety table"/>
+          <p:cNvPr id="5" name="AI and safety table"/>
           <p:cNvGraphicFramePr>
             <a:graphicFrameLocks noGrp="1"/>
           </p:cNvGraphicFramePr>
@@ -3571,766 +4059,6 @@
             <a:pPr algn="r"/>
             <a:fld id="{F7021451-1387-4CA6-816F-3879F97B5CBC}" type="slidenum">
               <a:rPr b="0" lang="en-US"/>
-              <a:t>3</a:t>
-            </a:fld>
-            <a:endParaRPr lang="en-US"/>
-          </a:p>
-        </p:txBody>
-      </p:sp>
-    </p:spTree>
-  </p:cSld>
-  <p:clrMapOvr>
-    <a:masterClrMapping/>
-  </p:clrMapOvr>
-</p:sld>
-</file>
-
-<file path=ppt/slides/slide4.xml><?xml version="1.0" encoding="utf-8"?>
-<p:sld xmlns:a="http://schemas.openxmlformats.org/drawingml/2006/main" xmlns:r="http://schemas.openxmlformats.org/officeDocument/2006/relationships" xmlns:p="http://schemas.openxmlformats.org/presentationml/2006/main">
-  <p:cSld name="Slide 4">
-    <p:spTree>
-      <p:nvGrpSpPr>
-        <p:cNvPr id="1" name=""/>
-        <p:cNvGrpSpPr/>
-        <p:nvPr/>
-      </p:nvGrpSpPr>
-      <p:grpSpPr>
-        <a:xfrm>
-          <a:off x="0" y="0"/>
-          <a:ext cx="0" cy="0"/>
-          <a:chOff x="0" y="0"/>
-          <a:chExt cx="0" cy="0"/>
-        </a:xfrm>
-      </p:grpSpPr>
-      <p:sp>
-        <p:nvSpPr>
-          <p:cNvPr id="2" name="Text 0"/>
-          <p:cNvSpPr/>
-          <p:nvPr>
-            <p:ph idx="100" type="title" hasCustomPrompt="1"/>
-          </p:nvPr>
-        </p:nvSpPr>
-        <p:spPr>
-          <a:xfrm>
-            <a:off x="548640" y="320040"/>
-            <a:ext cx="11064240" cy="731520"/>
-          </a:xfrm>
-          <a:prstGeom prst="rect">
-            <a:avLst/>
-          </a:prstGeom>
-          <a:noFill/>
-          <a:ln/>
-        </p:spPr>
-        <p:txBody>
-          <a:bodyPr wrap="square" lIns="0" tIns="0" rIns="0" bIns="0" rtlCol="0" anchor="ctr"/>
-          <a:lstStyle/>
-          <a:p>
-            <a:pPr algn="l" indent="0" marL="0">
-              <a:buNone/>
-            </a:pPr>
-            <a:r>
-              <a:rPr lang="en-US" sz="3200" b="1" dirty="0">
-                <a:solidFill>
-                  <a:schemeClr val="tx1"/>
-                </a:solidFill>
-              </a:rPr>
-              <a:t>How prompts drive Lele</a:t>
-            </a:r>
-            <a:endParaRPr lang="en-US" sz="3200" dirty="0"/>
-          </a:p>
-        </p:txBody>
-      </p:sp>
-      <p:sp>
-        <p:nvSpPr>
-          <p:cNvPr id="3" name="Rules first banner"/>
-          <p:cNvSpPr/>
-          <p:nvPr/>
-        </p:nvSpPr>
-        <p:spPr>
-          <a:xfrm>
-            <a:off x="548640" y="1188720"/>
-            <a:ext cx="11064240" cy="685800"/>
-          </a:xfrm>
-          <a:prstGeom prst="roundRect">
-            <a:avLst>
-              <a:gd name="adj" fmla="val 16000"/>
-            </a:avLst>
-          </a:prstGeom>
-          <a:solidFill>
-            <a:schemeClr val="accent3"/>
-          </a:solidFill>
-          <a:ln w="12700">
-            <a:solidFill>
-              <a:schemeClr val="accent3"/>
-            </a:solidFill>
-            <a:prstDash val="solid"/>
-          </a:ln>
-        </p:spPr>
-      </p:sp>
-      <p:sp>
-        <p:nvSpPr>
-          <p:cNvPr id="4" name="Text 2"/>
-          <p:cNvSpPr txBox="1"/>
-          <p:nvPr/>
-        </p:nvSpPr>
-        <p:spPr>
-          <a:xfrm>
-            <a:off x="777240" y="1188720"/>
-            <a:ext cx="10607040" cy="685800"/>
-          </a:xfrm>
-          <a:prstGeom prst="rect">
-            <a:avLst/>
-          </a:prstGeom>
-          <a:noFill/>
-          <a:ln/>
-        </p:spPr>
-        <p:txBody>
-          <a:bodyPr wrap="square" lIns="0" tIns="0" rIns="0" bIns="0" rtlCol="0" anchor="ctr"/>
-          <a:lstStyle/>
-          <a:p>
-            <a:pPr indent="0" marL="0">
-              <a:buNone/>
-            </a:pPr>
-            <a:r>
-              <a:rPr lang="en-US" sz="1500" b="1" dirty="0">
-                <a:solidFill>
-                  <a:schemeClr val="accent1"/>
-                </a:solidFill>
-              </a:rPr>
-              <a:t>Rules first. </a:t>
-            </a:r>
-            <a:pPr indent="0" marL="0">
-              <a:buNone/>
-            </a:pPr>
-            <a:r>
-              <a:rPr lang="en-US" sz="1500" dirty="0">
-                <a:solidFill>
-                  <a:schemeClr val="tx1"/>
-                </a:solidFill>
-              </a:rPr>
-              <a:t>Red flags, medicine dose questions and pain limits are answered by tested code before any model sees a message.</a:t>
-            </a:r>
-            <a:endParaRPr lang="en-US" sz="1500" dirty="0"/>
-          </a:p>
-        </p:txBody>
-      </p:sp>
-      <p:sp>
-        <p:nvSpPr>
-          <p:cNvPr id="5" name="Card Chat"/>
-          <p:cNvSpPr/>
-          <p:nvPr/>
-        </p:nvSpPr>
-        <p:spPr>
-          <a:xfrm>
-            <a:off x="548640" y="2148840"/>
-            <a:ext cx="3520440" cy="2971800"/>
-          </a:xfrm>
-          <a:prstGeom prst="roundRect">
-            <a:avLst>
-              <a:gd name="adj" fmla="val 4615"/>
-            </a:avLst>
-          </a:prstGeom>
-          <a:solidFill>
-            <a:schemeClr val="bg2"/>
-          </a:solidFill>
-          <a:ln w="9525">
-            <a:solidFill>
-              <a:srgbClr val="E1E7E3"/>
-            </a:solidFill>
-            <a:prstDash val="solid"/>
-          </a:ln>
-        </p:spPr>
-      </p:sp>
-      <p:sp>
-        <p:nvSpPr>
-          <p:cNvPr id="6" name="Step 1"/>
-          <p:cNvSpPr/>
-          <p:nvPr/>
-        </p:nvSpPr>
-        <p:spPr>
-          <a:xfrm>
-            <a:off x="822960" y="2377440"/>
-            <a:ext cx="502920" cy="502920"/>
-          </a:xfrm>
-          <a:prstGeom prst="ellipse">
-            <a:avLst/>
-          </a:prstGeom>
-          <a:solidFill>
-            <a:schemeClr val="accent1"/>
-          </a:solidFill>
-          <a:ln w="12700">
-            <a:solidFill>
-              <a:schemeClr val="accent1"/>
-            </a:solidFill>
-            <a:prstDash val="solid"/>
-          </a:ln>
-        </p:spPr>
-      </p:sp>
-      <p:sp>
-        <p:nvSpPr>
-          <p:cNvPr id="7" name="Text 5"/>
-          <p:cNvSpPr txBox="1"/>
-          <p:nvPr/>
-        </p:nvSpPr>
-        <p:spPr>
-          <a:xfrm>
-            <a:off x="822960" y="2377440"/>
-            <a:ext cx="502920" cy="502920"/>
-          </a:xfrm>
-          <a:prstGeom prst="rect">
-            <a:avLst/>
-          </a:prstGeom>
-          <a:noFill/>
-          <a:ln/>
-        </p:spPr>
-        <p:txBody>
-          <a:bodyPr wrap="square" lIns="0" tIns="0" rIns="0" bIns="0" rtlCol="0" anchor="ctr"/>
-          <a:lstStyle/>
-          <a:p>
-            <a:pPr algn="ctr" indent="0" marL="0">
-              <a:buNone/>
-            </a:pPr>
-            <a:r>
-              <a:rPr lang="en-US" sz="1800" b="1" dirty="0">
-                <a:solidFill>
-                  <a:schemeClr val="bg1"/>
-                </a:solidFill>
-              </a:rPr>
-              <a:t>1</a:t>
-            </a:r>
-            <a:endParaRPr lang="en-US" sz="1800" dirty="0"/>
-          </a:p>
-        </p:txBody>
-      </p:sp>
-      <p:sp>
-        <p:nvSpPr>
-          <p:cNvPr id="8" name="Text 6"/>
-          <p:cNvSpPr txBox="1"/>
-          <p:nvPr/>
-        </p:nvSpPr>
-        <p:spPr>
-          <a:xfrm>
-            <a:off x="1463040" y="2377440"/>
-            <a:ext cx="2423160" cy="502920"/>
-          </a:xfrm>
-          <a:prstGeom prst="rect">
-            <a:avLst/>
-          </a:prstGeom>
-          <a:noFill/>
-          <a:ln/>
-        </p:spPr>
-        <p:txBody>
-          <a:bodyPr wrap="square" lIns="0" tIns="0" rIns="0" bIns="0" rtlCol="0" anchor="ctr"/>
-          <a:lstStyle/>
-          <a:p>
-            <a:pPr indent="0" marL="0">
-              <a:buNone/>
-            </a:pPr>
-            <a:r>
-              <a:rPr lang="en-US" sz="1900" b="1" dirty="0">
-                <a:solidFill>
-                  <a:schemeClr val="tx1"/>
-                </a:solidFill>
-              </a:rPr>
-              <a:t>Chat</a:t>
-            </a:r>
-            <a:endParaRPr lang="en-US" sz="1900" dirty="0"/>
-          </a:p>
-        </p:txBody>
-      </p:sp>
-      <p:sp>
-        <p:nvSpPr>
-          <p:cNvPr id="9" name="Text 7"/>
-          <p:cNvSpPr txBox="1"/>
-          <p:nvPr/>
-        </p:nvSpPr>
-        <p:spPr>
-          <a:xfrm>
-            <a:off x="822960" y="3063240"/>
-            <a:ext cx="3017520" cy="1920240"/>
-          </a:xfrm>
-          <a:prstGeom prst="rect">
-            <a:avLst/>
-          </a:prstGeom>
-          <a:noFill/>
-          <a:ln/>
-        </p:spPr>
-        <p:txBody>
-          <a:bodyPr wrap="square" lIns="0" tIns="0" rIns="0" bIns="0" rtlCol="0" anchor="t"/>
-          <a:lstStyle/>
-          <a:p>
-            <a:pPr indent="0" marL="0">
-              <a:spcAft>
-                <a:spcPts val="1000"/>
-              </a:spcAft>
-              <a:buNone/>
-            </a:pPr>
-            <a:r>
-              <a:rPr lang="en-US" sz="1400" dirty="0">
-                <a:solidFill>
-                  <a:schemeClr val="tx1"/>
-                </a:solidFill>
-              </a:rPr>
-              <a:t>Sent: the person's program, goals, measurements, last session and care notes, then the question and a reminder of Lele's voice.</a:t>
-            </a:r>
-            <a:endParaRPr lang="en-US" sz="1400" dirty="0"/>
-          </a:p>
-          <a:p>
-            <a:pPr indent="0" marL="0">
-              <a:buNone/>
-            </a:pPr>
-            <a:r>
-              <a:rPr lang="en-US" sz="1400" dirty="0">
-                <a:solidFill>
-                  <a:schemeClr val="tx1"/>
-                </a:solidFill>
-              </a:rPr>
-              <a:t>Back: a reply in Lele's voice, under 120 words, quoting real numbers. A "remember" line becomes a care note only after code checks it.</a:t>
-            </a:r>
-            <a:endParaRPr lang="en-US" sz="1400" dirty="0"/>
-          </a:p>
-        </p:txBody>
-      </p:sp>
-      <p:sp>
-        <p:nvSpPr>
-          <p:cNvPr id="10" name="Card PLAN REQUEST"/>
-          <p:cNvSpPr/>
-          <p:nvPr/>
-        </p:nvSpPr>
-        <p:spPr>
-          <a:xfrm>
-            <a:off x="4320540" y="2148840"/>
-            <a:ext cx="3520440" cy="2971800"/>
-          </a:xfrm>
-          <a:prstGeom prst="roundRect">
-            <a:avLst>
-              <a:gd name="adj" fmla="val 4615"/>
-            </a:avLst>
-          </a:prstGeom>
-          <a:solidFill>
-            <a:schemeClr val="bg2"/>
-          </a:solidFill>
-          <a:ln w="9525">
-            <a:solidFill>
-              <a:srgbClr val="E1E7E3"/>
-            </a:solidFill>
-            <a:prstDash val="solid"/>
-          </a:ln>
-        </p:spPr>
-      </p:sp>
-      <p:sp>
-        <p:nvSpPr>
-          <p:cNvPr id="11" name="Step 2"/>
-          <p:cNvSpPr/>
-          <p:nvPr/>
-        </p:nvSpPr>
-        <p:spPr>
-          <a:xfrm>
-            <a:off x="4594860" y="2377440"/>
-            <a:ext cx="502920" cy="502920"/>
-          </a:xfrm>
-          <a:prstGeom prst="ellipse">
-            <a:avLst/>
-          </a:prstGeom>
-          <a:solidFill>
-            <a:schemeClr val="accent1"/>
-          </a:solidFill>
-          <a:ln w="12700">
-            <a:solidFill>
-              <a:schemeClr val="accent1"/>
-            </a:solidFill>
-            <a:prstDash val="solid"/>
-          </a:ln>
-        </p:spPr>
-      </p:sp>
-      <p:sp>
-        <p:nvSpPr>
-          <p:cNvPr id="12" name="Text 10"/>
-          <p:cNvSpPr txBox="1"/>
-          <p:nvPr/>
-        </p:nvSpPr>
-        <p:spPr>
-          <a:xfrm>
-            <a:off x="4594860" y="2377440"/>
-            <a:ext cx="502920" cy="502920"/>
-          </a:xfrm>
-          <a:prstGeom prst="rect">
-            <a:avLst/>
-          </a:prstGeom>
-          <a:noFill/>
-          <a:ln/>
-        </p:spPr>
-        <p:txBody>
-          <a:bodyPr wrap="square" lIns="0" tIns="0" rIns="0" bIns="0" rtlCol="0" anchor="ctr"/>
-          <a:lstStyle/>
-          <a:p>
-            <a:pPr algn="ctr" indent="0" marL="0">
-              <a:buNone/>
-            </a:pPr>
-            <a:r>
-              <a:rPr lang="en-US" sz="1800" b="1" dirty="0">
-                <a:solidFill>
-                  <a:schemeClr val="bg1"/>
-                </a:solidFill>
-              </a:rPr>
-              <a:t>2</a:t>
-            </a:r>
-            <a:endParaRPr lang="en-US" sz="1800" dirty="0"/>
-          </a:p>
-        </p:txBody>
-      </p:sp>
-      <p:sp>
-        <p:nvSpPr>
-          <p:cNvPr id="13" name="Text 11"/>
-          <p:cNvSpPr txBox="1"/>
-          <p:nvPr/>
-        </p:nvSpPr>
-        <p:spPr>
-          <a:xfrm>
-            <a:off x="5234940" y="2377440"/>
-            <a:ext cx="2423160" cy="502920"/>
-          </a:xfrm>
-          <a:prstGeom prst="rect">
-            <a:avLst/>
-          </a:prstGeom>
-          <a:noFill/>
-          <a:ln/>
-        </p:spPr>
-        <p:txBody>
-          <a:bodyPr wrap="square" lIns="0" tIns="0" rIns="0" bIns="0" rtlCol="0" anchor="ctr"/>
-          <a:lstStyle/>
-          <a:p>
-            <a:pPr indent="0" marL="0">
-              <a:buNone/>
-            </a:pPr>
-            <a:r>
-              <a:rPr lang="en-US" sz="1900" b="1" dirty="0">
-                <a:solidFill>
-                  <a:schemeClr val="tx1"/>
-                </a:solidFill>
-              </a:rPr>
-              <a:t>PLAN REQUEST</a:t>
-            </a:r>
-            <a:endParaRPr lang="en-US" sz="1900" dirty="0"/>
-          </a:p>
-        </p:txBody>
-      </p:sp>
-      <p:sp>
-        <p:nvSpPr>
-          <p:cNvPr id="14" name="Text 12"/>
-          <p:cNvSpPr txBox="1"/>
-          <p:nvPr/>
-        </p:nvSpPr>
-        <p:spPr>
-          <a:xfrm>
-            <a:off x="4594860" y="3063240"/>
-            <a:ext cx="3017520" cy="1920240"/>
-          </a:xfrm>
-          <a:prstGeom prst="rect">
-            <a:avLst/>
-          </a:prstGeom>
-          <a:noFill/>
-          <a:ln/>
-        </p:spPr>
-        <p:txBody>
-          <a:bodyPr wrap="square" lIns="0" tIns="0" rIns="0" bIns="0" rtlCol="0" anchor="t"/>
-          <a:lstStyle/>
-          <a:p>
-            <a:pPr indent="0" marL="0">
-              <a:spcAft>
-                <a:spcPts val="1000"/>
-              </a:spcAft>
-              <a:buNone/>
-            </a:pPr>
-            <a:r>
-              <a:rPr lang="en-US" sz="1400" dirty="0">
-                <a:solidFill>
-                  <a:schemeClr val="tx1"/>
-                </a:solidFill>
-              </a:rPr>
-              <a:t>Sent: goals, minutes a day, experience, areas to protect, the physio's precautions, and the only exercise ids allowed.</a:t>
-            </a:r>
-            <a:endParaRPr lang="en-US" sz="1400" dirty="0"/>
-          </a:p>
-          <a:p>
-            <a:pPr indent="0" marL="0">
-              <a:buNone/>
-            </a:pPr>
-            <a:r>
-              <a:rPr lang="en-US" sz="1400" dirty="0">
-                <a:solidFill>
-                  <a:schemeClr val="tx1"/>
-                </a:solidFill>
-              </a:rPr>
-              <a:t>Back: a JSON draft, then a schema check and the contraindication checker. A physio patient's plan waits for approval.</a:t>
-            </a:r>
-            <a:endParaRPr lang="en-US" sz="1400" dirty="0"/>
-          </a:p>
-        </p:txBody>
-      </p:sp>
-      <p:sp>
-        <p:nvSpPr>
-          <p:cNvPr id="15" name="Card CLINICIAN BRIEF"/>
-          <p:cNvSpPr/>
-          <p:nvPr/>
-        </p:nvSpPr>
-        <p:spPr>
-          <a:xfrm>
-            <a:off x="8092440" y="2148840"/>
-            <a:ext cx="3520440" cy="2971800"/>
-          </a:xfrm>
-          <a:prstGeom prst="roundRect">
-            <a:avLst>
-              <a:gd name="adj" fmla="val 4615"/>
-            </a:avLst>
-          </a:prstGeom>
-          <a:solidFill>
-            <a:schemeClr val="bg2"/>
-          </a:solidFill>
-          <a:ln w="9525">
-            <a:solidFill>
-              <a:srgbClr val="E1E7E3"/>
-            </a:solidFill>
-            <a:prstDash val="solid"/>
-          </a:ln>
-        </p:spPr>
-      </p:sp>
-      <p:sp>
-        <p:nvSpPr>
-          <p:cNvPr id="16" name="Step 3"/>
-          <p:cNvSpPr/>
-          <p:nvPr/>
-        </p:nvSpPr>
-        <p:spPr>
-          <a:xfrm>
-            <a:off x="8366760" y="2377440"/>
-            <a:ext cx="502920" cy="502920"/>
-          </a:xfrm>
-          <a:prstGeom prst="ellipse">
-            <a:avLst/>
-          </a:prstGeom>
-          <a:solidFill>
-            <a:schemeClr val="accent1"/>
-          </a:solidFill>
-          <a:ln w="12700">
-            <a:solidFill>
-              <a:schemeClr val="accent1"/>
-            </a:solidFill>
-            <a:prstDash val="solid"/>
-          </a:ln>
-        </p:spPr>
-      </p:sp>
-      <p:sp>
-        <p:nvSpPr>
-          <p:cNvPr id="17" name="Text 15"/>
-          <p:cNvSpPr txBox="1"/>
-          <p:nvPr/>
-        </p:nvSpPr>
-        <p:spPr>
-          <a:xfrm>
-            <a:off x="8366760" y="2377440"/>
-            <a:ext cx="502920" cy="502920"/>
-          </a:xfrm>
-          <a:prstGeom prst="rect">
-            <a:avLst/>
-          </a:prstGeom>
-          <a:noFill/>
-          <a:ln/>
-        </p:spPr>
-        <p:txBody>
-          <a:bodyPr wrap="square" lIns="0" tIns="0" rIns="0" bIns="0" rtlCol="0" anchor="ctr"/>
-          <a:lstStyle/>
-          <a:p>
-            <a:pPr algn="ctr" indent="0" marL="0">
-              <a:buNone/>
-            </a:pPr>
-            <a:r>
-              <a:rPr lang="en-US" sz="1800" b="1" dirty="0">
-                <a:solidFill>
-                  <a:schemeClr val="bg1"/>
-                </a:solidFill>
-              </a:rPr>
-              <a:t>3</a:t>
-            </a:r>
-            <a:endParaRPr lang="en-US" sz="1800" dirty="0"/>
-          </a:p>
-        </p:txBody>
-      </p:sp>
-      <p:sp>
-        <p:nvSpPr>
-          <p:cNvPr id="18" name="Text 16"/>
-          <p:cNvSpPr txBox="1"/>
-          <p:nvPr/>
-        </p:nvSpPr>
-        <p:spPr>
-          <a:xfrm>
-            <a:off x="9006840" y="2377440"/>
-            <a:ext cx="2423160" cy="502920"/>
-          </a:xfrm>
-          <a:prstGeom prst="rect">
-            <a:avLst/>
-          </a:prstGeom>
-          <a:noFill/>
-          <a:ln/>
-        </p:spPr>
-        <p:txBody>
-          <a:bodyPr wrap="square" lIns="0" tIns="0" rIns="0" bIns="0" rtlCol="0" anchor="ctr"/>
-          <a:lstStyle/>
-          <a:p>
-            <a:pPr indent="0" marL="0">
-              <a:buNone/>
-            </a:pPr>
-            <a:r>
-              <a:rPr lang="en-US" sz="1900" b="1" dirty="0">
-                <a:solidFill>
-                  <a:schemeClr val="tx1"/>
-                </a:solidFill>
-              </a:rPr>
-              <a:t>CLINICIAN BRIEF</a:t>
-            </a:r>
-            <a:endParaRPr lang="en-US" sz="1900" dirty="0"/>
-          </a:p>
-        </p:txBody>
-      </p:sp>
-      <p:sp>
-        <p:nvSpPr>
-          <p:cNvPr id="19" name="Text 17"/>
-          <p:cNvSpPr txBox="1"/>
-          <p:nvPr/>
-        </p:nvSpPr>
-        <p:spPr>
-          <a:xfrm>
-            <a:off x="8366760" y="3063240"/>
-            <a:ext cx="3017520" cy="1920240"/>
-          </a:xfrm>
-          <a:prstGeom prst="rect">
-            <a:avLst/>
-          </a:prstGeom>
-          <a:noFill/>
-          <a:ln/>
-        </p:spPr>
-        <p:txBody>
-          <a:bodyPr wrap="square" lIns="0" tIns="0" rIns="0" bIns="0" rtlCol="0" anchor="t"/>
-          <a:lstStyle/>
-          <a:p>
-            <a:pPr indent="0" marL="0">
-              <a:spcAft>
-                <a:spcPts val="1000"/>
-              </a:spcAft>
-              <a:buNone/>
-            </a:pPr>
-            <a:r>
-              <a:rPr lang="en-US" sz="1400" dirty="0">
-                <a:solidFill>
-                  <a:schemeClr val="tx1"/>
-                </a:solidFill>
-              </a:rPr>
-              <a:t>Sent: adherence, key measures with numbers, recent reports, care notes and pending approvals, all computed by code.</a:t>
-            </a:r>
-            <a:endParaRPr lang="en-US" sz="1400" dirty="0"/>
-          </a:p>
-          <a:p>
-            <a:pPr indent="0" marL="0">
-              <a:buNone/>
-            </a:pPr>
-            <a:r>
-              <a:rPr lang="en-US" sz="1400" dirty="0">
-                <a:solidFill>
-                  <a:schemeClr val="tx1"/>
-                </a:solidFill>
-              </a:rPr>
-              <a:t>Back: 4 to 6 lines for the physio, with what the knowledge base says is typical at this stage.</a:t>
-            </a:r>
-            <a:endParaRPr lang="en-US" sz="1400" dirty="0"/>
-          </a:p>
-        </p:txBody>
-      </p:sp>
-      <p:sp>
-        <p:nvSpPr>
-          <p:cNvPr id="20" name="Text 18"/>
-          <p:cNvSpPr txBox="1"/>
-          <p:nvPr/>
-        </p:nvSpPr>
-        <p:spPr>
-          <a:xfrm>
-            <a:off x="548640" y="5440680"/>
-            <a:ext cx="11064240" cy="548640"/>
-          </a:xfrm>
-          <a:prstGeom prst="rect">
-            <a:avLst/>
-          </a:prstGeom>
-          <a:noFill/>
-          <a:ln/>
-        </p:spPr>
-        <p:txBody>
-          <a:bodyPr wrap="square" lIns="0" tIns="0" rIns="0" bIns="0" rtlCol="0" anchor="ctr"/>
-          <a:lstStyle/>
-          <a:p>
-            <a:pPr indent="0" marL="0">
-              <a:buNone/>
-            </a:pPr>
-            <a:r>
-              <a:rPr lang="en-US" sz="1500" b="1" dirty="0">
-                <a:solidFill>
-                  <a:schemeClr val="accent1"/>
-                </a:solidFill>
-              </a:rPr>
-              <a:t>One agent, three modes. </a:t>
-            </a:r>
-            <a:pPr indent="0" marL="0">
-              <a:buNone/>
-            </a:pPr>
-            <a:r>
-              <a:rPr lang="en-US" sz="1500" dirty="0">
-                <a:solidFill>
-                  <a:schemeClr val="tx1"/>
-                </a:solidFill>
-              </a:rPr>
-              <a:t>The server starts each message with its mode, and Lele's prompt on ADP has a section for each. The same knowledge base grounds all three.</a:t>
-            </a:r>
-            <a:endParaRPr lang="en-US" sz="1500" dirty="0"/>
-          </a:p>
-        </p:txBody>
-      </p:sp>
-      <p:sp>
-        <p:nvSpPr>
-          <p:cNvPr id="25" name="Slide Number Placeholder 0"/>
-          <p:cNvSpPr>
-            <a:spLocks noGrp="1"/>
-          </p:cNvSpPr>
-          <p:nvPr>
-            <p:ph type="sldNum" sz="quarter" idx="4294967295"/>
-          </p:nvPr>
-        </p:nvSpPr>
-        <p:spPr>
-          <a:xfrm>
-            <a:off x="11155680" y="6400800"/>
-            <a:ext cx="457200" cy="274320"/>
-          </a:xfrm>
-          <a:prstGeom prst="rect">
-            <a:avLst/>
-          </a:prstGeom>
-          <a:extLst>
-            <a:ext uri="{C572A759-6A51-4108-AA02-DFA0A04FC94B}">
-              <ma14:wrappingTextBoxFlag xmlns:ma14="http://schemas.microsoft.com/office/mac/drawingml/2011/main" val="0"/>
-            </a:ext>
-          </a:extLst>
-        </p:spPr>
-        <p:txBody>
-          <a:bodyPr/>
-          <a:lstStyle>
-            <a:lvl1pPr>
-              <a:defRPr sz="1000">
-                <a:solidFill>
-                  <a:schemeClr val="accent4"/>
-                </a:solidFill>
-              </a:defRPr>
-            </a:lvl1pPr>
-          </a:lstStyle>
-          <a:p>
-            <a:pPr algn="r"/>
-            <a:fld id="{F7021451-1387-4CA6-816F-3879F97B5CBC}" type="slidenum">
-              <a:rPr b="0" lang="en-US"/>
               <a:t>4</a:t>
             </a:fld>
             <a:endParaRPr lang="en-US"/>
@@ -4394,7 +4122,7 @@
                   <a:schemeClr val="tx1"/>
                 </a:solidFill>
               </a:rPr>
-              <a:t>Built with</a:t>
+              <a:t>How prompts drive Lele</a:t>
             </a:r>
             <a:endParaRPr lang="en-US" sz="3200" dirty="0"/>
           </a:p>
@@ -4402,18 +4130,92 @@
       </p:sp>
       <p:sp>
         <p:nvSpPr>
-          <p:cNvPr id="3" name="Column Tencent Cloud and tools"/>
+          <p:cNvPr id="3" name="Rules first banner"/>
           <p:cNvSpPr/>
           <p:nvPr/>
         </p:nvSpPr>
         <p:spPr>
           <a:xfrm>
-            <a:off x="548640" y="1234440"/>
-            <a:ext cx="3520440" cy="3840480"/>
+            <a:off x="548640" y="1188720"/>
+            <a:ext cx="11064240" cy="685800"/>
           </a:xfrm>
           <a:prstGeom prst="roundRect">
             <a:avLst>
-              <a:gd name="adj" fmla="val 3896"/>
+              <a:gd name="adj" fmla="val 16000"/>
+            </a:avLst>
+          </a:prstGeom>
+          <a:solidFill>
+            <a:schemeClr val="accent3"/>
+          </a:solidFill>
+          <a:ln w="12700">
+            <a:solidFill>
+              <a:schemeClr val="accent3"/>
+            </a:solidFill>
+            <a:prstDash val="solid"/>
+          </a:ln>
+        </p:spPr>
+      </p:sp>
+      <p:sp>
+        <p:nvSpPr>
+          <p:cNvPr id="4" name="Text 2"/>
+          <p:cNvSpPr txBox="1"/>
+          <p:nvPr/>
+        </p:nvSpPr>
+        <p:spPr>
+          <a:xfrm>
+            <a:off x="777240" y="1188720"/>
+            <a:ext cx="10607040" cy="685800"/>
+          </a:xfrm>
+          <a:prstGeom prst="rect">
+            <a:avLst/>
+          </a:prstGeom>
+          <a:noFill/>
+          <a:ln/>
+        </p:spPr>
+        <p:txBody>
+          <a:bodyPr wrap="square" lIns="0" tIns="0" rIns="0" bIns="0" rtlCol="0" anchor="ctr"/>
+          <a:lstStyle/>
+          <a:p>
+            <a:pPr indent="0" marL="0">
+              <a:buNone/>
+            </a:pPr>
+            <a:r>
+              <a:rPr lang="en-US" sz="1500" b="1" dirty="0">
+                <a:solidFill>
+                  <a:schemeClr val="accent1"/>
+                </a:solidFill>
+              </a:rPr>
+              <a:t>Rules first. </a:t>
+            </a:r>
+            <a:pPr indent="0" marL="0">
+              <a:buNone/>
+            </a:pPr>
+            <a:r>
+              <a:rPr lang="en-US" sz="1500" dirty="0">
+                <a:solidFill>
+                  <a:schemeClr val="tx1"/>
+                </a:solidFill>
+              </a:rPr>
+              <a:t>Red flags, medicine dose questions and pain limits are answered by tested code before any model sees a message.</a:t>
+            </a:r>
+            <a:endParaRPr lang="en-US" sz="1500" dirty="0"/>
+          </a:p>
+        </p:txBody>
+      </p:sp>
+      <p:sp>
+        <p:nvSpPr>
+          <p:cNvPr id="5" name="Card Chat"/>
+          <p:cNvSpPr/>
+          <p:nvPr/>
+        </p:nvSpPr>
+        <p:spPr>
+          <a:xfrm>
+            <a:off x="548640" y="2148840"/>
+            <a:ext cx="3520440" cy="2971800"/>
+          </a:xfrm>
+          <a:prstGeom prst="roundRect">
+            <a:avLst>
+              <a:gd name="adj" fmla="val 4615"/>
             </a:avLst>
           </a:prstGeom>
           <a:solidFill>
@@ -4429,14 +4231,39 @@
       </p:sp>
       <p:sp>
         <p:nvSpPr>
-          <p:cNvPr id="4" name="Text 2"/>
+          <p:cNvPr id="6" name="Step 1"/>
+          <p:cNvSpPr/>
+          <p:nvPr/>
+        </p:nvSpPr>
+        <p:spPr>
+          <a:xfrm>
+            <a:off x="822960" y="2377440"/>
+            <a:ext cx="502920" cy="502920"/>
+          </a:xfrm>
+          <a:prstGeom prst="ellipse">
+            <a:avLst/>
+          </a:prstGeom>
+          <a:solidFill>
+            <a:schemeClr val="accent1"/>
+          </a:solidFill>
+          <a:ln w="12700">
+            <a:solidFill>
+              <a:schemeClr val="accent1"/>
+            </a:solidFill>
+            <a:prstDash val="solid"/>
+          </a:ln>
+        </p:spPr>
+      </p:sp>
+      <p:sp>
+        <p:nvSpPr>
+          <p:cNvPr id="7" name="Text 5"/>
           <p:cNvSpPr txBox="1"/>
           <p:nvPr/>
         </p:nvSpPr>
         <p:spPr>
           <a:xfrm>
-            <a:off x="822960" y="1417320"/>
-            <a:ext cx="3017520" cy="457200"/>
+            <a:off x="822960" y="2377440"/>
+            <a:ext cx="502920" cy="502920"/>
           </a:xfrm>
           <a:prstGeom prst="rect">
             <a:avLst/>
@@ -4448,16 +4275,16 @@
           <a:bodyPr wrap="square" lIns="0" tIns="0" rIns="0" bIns="0" rtlCol="0" anchor="ctr"/>
           <a:lstStyle/>
           <a:p>
-            <a:pPr indent="0" marL="0">
+            <a:pPr algn="ctr" indent="0" marL="0">
               <a:buNone/>
             </a:pPr>
             <a:r>
               <a:rPr lang="en-US" sz="1800" b="1" dirty="0">
                 <a:solidFill>
-                  <a:schemeClr val="accent1"/>
-                </a:solidFill>
-              </a:rPr>
-              <a:t>Tencent Cloud and tools</a:t>
+                  <a:schemeClr val="bg1"/>
+                </a:solidFill>
+              </a:rPr>
+              <a:t>1</a:t>
             </a:r>
             <a:endParaRPr lang="en-US" sz="1800" dirty="0"/>
           </a:p>
@@ -4465,14 +4292,14 @@
       </p:sp>
       <p:sp>
         <p:nvSpPr>
-          <p:cNvPr id="5" name="Text 3"/>
+          <p:cNvPr id="8" name="Text 6"/>
           <p:cNvSpPr txBox="1"/>
           <p:nvPr/>
         </p:nvSpPr>
         <p:spPr>
           <a:xfrm>
-            <a:off x="822960" y="2011680"/>
-            <a:ext cx="3017520" cy="2926080"/>
+            <a:off x="1463040" y="2377440"/>
+            <a:ext cx="2423160" cy="502920"/>
           </a:xfrm>
           <a:prstGeom prst="rect">
             <a:avLst/>
@@ -4481,24 +4308,63 @@
           <a:ln/>
         </p:spPr>
         <p:txBody>
+          <a:bodyPr wrap="square" lIns="0" tIns="0" rIns="0" bIns="0" rtlCol="0" anchor="ctr"/>
+          <a:lstStyle/>
+          <a:p>
+            <a:pPr indent="0" marL="0">
+              <a:buNone/>
+            </a:pPr>
+            <a:r>
+              <a:rPr lang="en-US" sz="1900" b="1" dirty="0">
+                <a:solidFill>
+                  <a:schemeClr val="tx1"/>
+                </a:solidFill>
+              </a:rPr>
+              <a:t>Chat</a:t>
+            </a:r>
+            <a:endParaRPr lang="en-US" sz="1900" dirty="0"/>
+          </a:p>
+        </p:txBody>
+      </p:sp>
+      <p:sp>
+        <p:nvSpPr>
+          <p:cNvPr id="9" name="Text 7"/>
+          <p:cNvSpPr txBox="1"/>
+          <p:nvPr/>
+        </p:nvSpPr>
+        <p:spPr>
+          <a:xfrm>
+            <a:off x="822960" y="3063240"/>
+            <a:ext cx="3017520" cy="1920240"/>
+          </a:xfrm>
+          <a:prstGeom prst="rect">
+            <a:avLst/>
+          </a:prstGeom>
+          <a:noFill/>
+          <a:ln/>
+        </p:spPr>
+        <p:txBody>
           <a:bodyPr wrap="square" lIns="0" tIns="0" rIns="0" bIns="0" rtlCol="0" anchor="t"/>
           <a:lstStyle/>
           <a:p>
             <a:pPr indent="0" marL="0">
-              <a:buNone/>
-            </a:pPr>
-            <a:r>
-              <a:rPr lang="en-US" sz="1400" b="1" dirty="0">
+              <a:spcAft>
+                <a:spcPts val="1000"/>
+              </a:spcAft>
+              <a:buNone/>
+            </a:pPr>
+            <a:r>
+              <a:rPr lang="en-US" sz="1400" dirty="0">
                 <a:solidFill>
                   <a:schemeClr val="tx1"/>
                 </a:solidFill>
               </a:rPr>
-              <a:t>ADP: </a:t>
-            </a:r>
+              <a:t>Sent: the person's program, goals, measurements, last session and care notes, then the question and a reminder of Lele's voice.</a:t>
+            </a:r>
+            <a:endParaRPr lang="en-US" sz="1400" dirty="0"/>
+          </a:p>
+          <a:p>
             <a:pPr indent="0" marL="0">
-              <a:spcAft>
-                <a:spcPts val="1200"/>
-              </a:spcAft>
               <a:buNone/>
             </a:pPr>
             <a:r>
@@ -4507,110 +4373,26 @@
                   <a:schemeClr val="tx1"/>
                 </a:solidFill>
               </a:rPr>
-              <a:t>Lele on the Hy3 model with a 12-document knowledge base: chat, program drafts, the physio's summary</a:t>
+              <a:t>Back: a reply in Lele's voice, under 120 words, quoting real numbers. A "remember" line becomes a care note only after code checks it.</a:t>
             </a:r>
             <a:endParaRPr lang="en-US" sz="1400" dirty="0"/>
           </a:p>
-          <a:p>
-            <a:pPr indent="0" marL="0">
-              <a:buNone/>
-            </a:pPr>
-            <a:r>
-              <a:rPr lang="en-US" sz="1400" b="1" dirty="0">
-                <a:solidFill>
-                  <a:schemeClr val="tx1"/>
-                </a:solidFill>
-              </a:rPr>
-              <a:t>Lighthouse: </a:t>
-            </a:r>
-            <a:pPr indent="0" marL="0">
-              <a:spcAft>
-                <a:spcPts val="1200"/>
-              </a:spcAft>
-              <a:buNone/>
-            </a:pPr>
-            <a:r>
-              <a:rPr lang="en-US" sz="1400" dirty="0">
-                <a:solidFill>
-                  <a:schemeClr val="tx1"/>
-                </a:solidFill>
-              </a:rPr>
-              <a:t>the server, web app and clinician portal (Docker, Caddy, HTTPS)</a:t>
-            </a:r>
-            <a:endParaRPr lang="en-US" sz="1400" dirty="0"/>
-          </a:p>
-          <a:p>
-            <a:pPr indent="0" marL="0">
-              <a:buNone/>
-            </a:pPr>
-            <a:r>
-              <a:rPr lang="en-US" sz="1400" b="1" dirty="0">
-                <a:solidFill>
-                  <a:schemeClr val="tx1"/>
-                </a:solidFill>
-              </a:rPr>
-              <a:t>CodeBuddy / WorkBuddy: </a:t>
-            </a:r>
-            <a:pPr indent="0" marL="0">
-              <a:spcAft>
-                <a:spcPts val="1200"/>
-              </a:spcAft>
-              <a:buNone/>
-            </a:pPr>
-            <a:r>
-              <a:rPr lang="en-US" sz="1400" dirty="0">
-                <a:solidFill>
-                  <a:schemeClr val="tx1"/>
-                </a:solidFill>
-              </a:rPr>
-              <a:t>safety and ADP audits; fixes reviewed and merged</a:t>
-            </a:r>
-            <a:endParaRPr lang="en-US" sz="1400" dirty="0"/>
-          </a:p>
-          <a:p>
-            <a:pPr indent="0" marL="0">
-              <a:buNone/>
-            </a:pPr>
-            <a:r>
-              <a:rPr lang="en-US" sz="1400" b="1" dirty="0">
-                <a:solidFill>
-                  <a:schemeClr val="tx1"/>
-                </a:solidFill>
-              </a:rPr>
-              <a:t>Miora: </a:t>
-            </a:r>
-            <a:pPr indent="0" marL="0">
-              <a:spcAft>
-                <a:spcPts val="1200"/>
-              </a:spcAft>
-              <a:buNone/>
-            </a:pPr>
-            <a:r>
-              <a:rPr lang="en-US" sz="1400" dirty="0">
-                <a:solidFill>
-                  <a:schemeClr val="tx1"/>
-                </a:solidFill>
-              </a:rPr>
-              <a:t>logo, cover, app icon and the Lele mascot</a:t>
-            </a:r>
-            <a:endParaRPr lang="en-US" sz="1400" dirty="0"/>
-          </a:p>
-        </p:txBody>
-      </p:sp>
-      <p:sp>
-        <p:nvSpPr>
-          <p:cNvPr id="6" name="Column iPhone and web apps"/>
+        </p:txBody>
+      </p:sp>
+      <p:sp>
+        <p:nvSpPr>
+          <p:cNvPr id="10" name="Card PLAN REQUEST"/>
           <p:cNvSpPr/>
           <p:nvPr/>
         </p:nvSpPr>
         <p:spPr>
           <a:xfrm>
-            <a:off x="4320540" y="1234440"/>
-            <a:ext cx="3520440" cy="3840480"/>
+            <a:off x="4320540" y="2148840"/>
+            <a:ext cx="3520440" cy="2971800"/>
           </a:xfrm>
           <a:prstGeom prst="roundRect">
             <a:avLst>
-              <a:gd name="adj" fmla="val 3896"/>
+              <a:gd name="adj" fmla="val 4615"/>
             </a:avLst>
           </a:prstGeom>
           <a:solidFill>
@@ -4626,14 +4408,39 @@
       </p:sp>
       <p:sp>
         <p:nvSpPr>
-          <p:cNvPr id="7" name="Text 5"/>
+          <p:cNvPr id="11" name="Step 2"/>
+          <p:cNvSpPr/>
+          <p:nvPr/>
+        </p:nvSpPr>
+        <p:spPr>
+          <a:xfrm>
+            <a:off x="4594860" y="2377440"/>
+            <a:ext cx="502920" cy="502920"/>
+          </a:xfrm>
+          <a:prstGeom prst="ellipse">
+            <a:avLst/>
+          </a:prstGeom>
+          <a:solidFill>
+            <a:schemeClr val="accent1"/>
+          </a:solidFill>
+          <a:ln w="12700">
+            <a:solidFill>
+              <a:schemeClr val="accent1"/>
+            </a:solidFill>
+            <a:prstDash val="solid"/>
+          </a:ln>
+        </p:spPr>
+      </p:sp>
+      <p:sp>
+        <p:nvSpPr>
+          <p:cNvPr id="12" name="Text 10"/>
           <p:cNvSpPr txBox="1"/>
           <p:nvPr/>
         </p:nvSpPr>
         <p:spPr>
           <a:xfrm>
-            <a:off x="4594860" y="1417320"/>
-            <a:ext cx="3017520" cy="457200"/>
+            <a:off x="4594860" y="2377440"/>
+            <a:ext cx="502920" cy="502920"/>
           </a:xfrm>
           <a:prstGeom prst="rect">
             <a:avLst/>
@@ -4645,16 +4452,16 @@
           <a:bodyPr wrap="square" lIns="0" tIns="0" rIns="0" bIns="0" rtlCol="0" anchor="ctr"/>
           <a:lstStyle/>
           <a:p>
-            <a:pPr indent="0" marL="0">
+            <a:pPr algn="ctr" indent="0" marL="0">
               <a:buNone/>
             </a:pPr>
             <a:r>
               <a:rPr lang="en-US" sz="1800" b="1" dirty="0">
                 <a:solidFill>
-                  <a:schemeClr val="tx1"/>
-                </a:solidFill>
-              </a:rPr>
-              <a:t>iPhone and web apps</a:t>
+                  <a:schemeClr val="bg1"/>
+                </a:solidFill>
+              </a:rPr>
+              <a:t>2</a:t>
             </a:r>
             <a:endParaRPr lang="en-US" sz="1800" dirty="0"/>
           </a:p>
@@ -4662,14 +4469,14 @@
       </p:sp>
       <p:sp>
         <p:nvSpPr>
-          <p:cNvPr id="8" name="Text 6"/>
+          <p:cNvPr id="13" name="Text 11"/>
           <p:cNvSpPr txBox="1"/>
           <p:nvPr/>
         </p:nvSpPr>
         <p:spPr>
           <a:xfrm>
-            <a:off x="4594860" y="2011680"/>
-            <a:ext cx="3017520" cy="2926080"/>
+            <a:off x="5234940" y="2377440"/>
+            <a:ext cx="2423160" cy="502920"/>
           </a:xfrm>
           <a:prstGeom prst="rect">
             <a:avLst/>
@@ -4678,24 +4485,63 @@
           <a:ln/>
         </p:spPr>
         <p:txBody>
+          <a:bodyPr wrap="square" lIns="0" tIns="0" rIns="0" bIns="0" rtlCol="0" anchor="ctr"/>
+          <a:lstStyle/>
+          <a:p>
+            <a:pPr indent="0" marL="0">
+              <a:buNone/>
+            </a:pPr>
+            <a:r>
+              <a:rPr lang="en-US" sz="1900" b="1" dirty="0">
+                <a:solidFill>
+                  <a:schemeClr val="tx1"/>
+                </a:solidFill>
+              </a:rPr>
+              <a:t>PLAN REQUEST</a:t>
+            </a:r>
+            <a:endParaRPr lang="en-US" sz="1900" dirty="0"/>
+          </a:p>
+        </p:txBody>
+      </p:sp>
+      <p:sp>
+        <p:nvSpPr>
+          <p:cNvPr id="14" name="Text 12"/>
+          <p:cNvSpPr txBox="1"/>
+          <p:nvPr/>
+        </p:nvSpPr>
+        <p:spPr>
+          <a:xfrm>
+            <a:off x="4594860" y="3063240"/>
+            <a:ext cx="3017520" cy="1920240"/>
+          </a:xfrm>
+          <a:prstGeom prst="rect">
+            <a:avLst/>
+          </a:prstGeom>
+          <a:noFill/>
+          <a:ln/>
+        </p:spPr>
+        <p:txBody>
           <a:bodyPr wrap="square" lIns="0" tIns="0" rIns="0" bIns="0" rtlCol="0" anchor="t"/>
           <a:lstStyle/>
           <a:p>
             <a:pPr indent="0" marL="0">
-              <a:buNone/>
-            </a:pPr>
-            <a:r>
-              <a:rPr lang="en-US" sz="1400" b="1" dirty="0">
+              <a:spcAft>
+                <a:spcPts val="1000"/>
+              </a:spcAft>
+              <a:buNone/>
+            </a:pPr>
+            <a:r>
+              <a:rPr lang="en-US" sz="1400" dirty="0">
                 <a:solidFill>
                   <a:schemeClr val="tx1"/>
                 </a:solidFill>
               </a:rPr>
-              <a:t>Swift 6, SwiftUI: </a:t>
-            </a:r>
+              <a:t>Sent: goals, minutes a day, experience, areas to protect, the physio's precautions, and the only exercise ids allowed.</a:t>
+            </a:r>
+            <a:endParaRPr lang="en-US" sz="1400" dirty="0"/>
+          </a:p>
+          <a:p>
             <a:pPr indent="0" marL="0">
-              <a:spcAft>
-                <a:spcPts val="1200"/>
-              </a:spcAft>
               <a:buNone/>
             </a:pPr>
             <a:r>
@@ -4704,110 +4550,26 @@
                   <a:schemeClr val="tx1"/>
                 </a:solidFill>
               </a:rPr>
-              <a:t>feature modules in LaileKit</a:t>
+              <a:t>Back: a JSON draft, then a schema check and the contraindication checker. A physio patient's plan waits for approval.</a:t>
             </a:r>
             <a:endParaRPr lang="en-US" sz="1400" dirty="0"/>
           </a:p>
-          <a:p>
-            <a:pPr indent="0" marL="0">
-              <a:buNone/>
-            </a:pPr>
-            <a:r>
-              <a:rPr lang="en-US" sz="1400" b="1" dirty="0">
-                <a:solidFill>
-                  <a:schemeClr val="tx1"/>
-                </a:solidFill>
-              </a:rPr>
-              <a:t>Apple Vision, Speech: </a:t>
-            </a:r>
-            <a:pPr indent="0" marL="0">
-              <a:spcAft>
-                <a:spcPts val="1200"/>
-              </a:spcAft>
-              <a:buNone/>
-            </a:pPr>
-            <a:r>
-              <a:rPr lang="en-US" sz="1400" dirty="0">
-                <a:solidFill>
-                  <a:schemeClr val="tx1"/>
-                </a:solidFill>
-              </a:rPr>
-              <a:t>body pose for reps, holds and angles; spoken symptoms</a:t>
-            </a:r>
-            <a:endParaRPr lang="en-US" sz="1400" dirty="0"/>
-          </a:p>
-          <a:p>
-            <a:pPr indent="0" marL="0">
-              <a:buNone/>
-            </a:pPr>
-            <a:r>
-              <a:rPr lang="en-US" sz="1400" b="1" dirty="0">
-                <a:solidFill>
-                  <a:schemeClr val="tx1"/>
-                </a:solidFill>
-              </a:rPr>
-              <a:t>Web app: </a:t>
-            </a:r>
-            <a:pPr indent="0" marL="0">
-              <a:spcAft>
-                <a:spcPts val="1200"/>
-              </a:spcAft>
-              <a:buNone/>
-            </a:pPr>
-            <a:r>
-              <a:rPr lang="en-US" sz="1400" dirty="0">
-                <a:solidFill>
-                  <a:schemeClr val="tx1"/>
-                </a:solidFill>
-              </a:rPr>
-              <a:t>plain JavaScript, MediaPipe pose, the same API</a:t>
-            </a:r>
-            <a:endParaRPr lang="en-US" sz="1400" dirty="0"/>
-          </a:p>
-          <a:p>
-            <a:pPr indent="0" marL="0">
-              <a:buNone/>
-            </a:pPr>
-            <a:r>
-              <a:rPr lang="en-US" sz="1400" b="1" dirty="0">
-                <a:solidFill>
-                  <a:schemeClr val="tx1"/>
-                </a:solidFill>
-              </a:rPr>
-              <a:t>ElevenLabs: </a:t>
-            </a:r>
-            <a:pPr indent="0" marL="0">
-              <a:spcAft>
-                <a:spcPts val="1200"/>
-              </a:spcAft>
-              <a:buNone/>
-            </a:pPr>
-            <a:r>
-              <a:rPr lang="en-US" sz="1400" dirty="0">
-                <a:solidFill>
-                  <a:schemeClr val="tx1"/>
-                </a:solidFill>
-              </a:rPr>
-              <a:t>Lele's voice on phone and web, cached per line</a:t>
-            </a:r>
-            <a:endParaRPr lang="en-US" sz="1400" dirty="0"/>
-          </a:p>
-        </p:txBody>
-      </p:sp>
-      <p:sp>
-        <p:nvSpPr>
-          <p:cNvPr id="9" name="Column Server and shared code"/>
+        </p:txBody>
+      </p:sp>
+      <p:sp>
+        <p:nvSpPr>
+          <p:cNvPr id="15" name="Card CLINICIAN BRIEF"/>
           <p:cNvSpPr/>
           <p:nvPr/>
         </p:nvSpPr>
         <p:spPr>
           <a:xfrm>
-            <a:off x="8092440" y="1234440"/>
-            <a:ext cx="3520440" cy="3840480"/>
+            <a:off x="8092440" y="2148840"/>
+            <a:ext cx="3520440" cy="2971800"/>
           </a:xfrm>
           <a:prstGeom prst="roundRect">
             <a:avLst>
-              <a:gd name="adj" fmla="val 3896"/>
+              <a:gd name="adj" fmla="val 4615"/>
             </a:avLst>
           </a:prstGeom>
           <a:solidFill>
@@ -4823,196 +4585,24 @@
       </p:sp>
       <p:sp>
         <p:nvSpPr>
-          <p:cNvPr id="10" name="Text 8"/>
-          <p:cNvSpPr txBox="1"/>
-          <p:nvPr/>
-        </p:nvSpPr>
-        <p:spPr>
-          <a:xfrm>
-            <a:off x="8366760" y="1417320"/>
-            <a:ext cx="3017520" cy="457200"/>
-          </a:xfrm>
-          <a:prstGeom prst="rect">
-            <a:avLst/>
-          </a:prstGeom>
-          <a:noFill/>
-          <a:ln/>
-        </p:spPr>
-        <p:txBody>
-          <a:bodyPr wrap="square" lIns="0" tIns="0" rIns="0" bIns="0" rtlCol="0" anchor="ctr"/>
-          <a:lstStyle/>
-          <a:p>
-            <a:pPr indent="0" marL="0">
-              <a:buNone/>
-            </a:pPr>
-            <a:r>
-              <a:rPr lang="en-US" sz="1800" b="1" dirty="0">
-                <a:solidFill>
-                  <a:schemeClr val="accent2"/>
-                </a:solidFill>
-              </a:rPr>
-              <a:t>Server and shared code</a:t>
-            </a:r>
-            <a:endParaRPr lang="en-US" sz="1800" dirty="0"/>
-          </a:p>
-        </p:txBody>
-      </p:sp>
-      <p:sp>
-        <p:nvSpPr>
-          <p:cNvPr id="11" name="Text 9"/>
-          <p:cNvSpPr txBox="1"/>
-          <p:nvPr/>
-        </p:nvSpPr>
-        <p:spPr>
-          <a:xfrm>
-            <a:off x="8366760" y="2011680"/>
-            <a:ext cx="3017520" cy="2926080"/>
-          </a:xfrm>
-          <a:prstGeom prst="rect">
-            <a:avLst/>
-          </a:prstGeom>
-          <a:noFill/>
-          <a:ln/>
-        </p:spPr>
-        <p:txBody>
-          <a:bodyPr wrap="square" lIns="0" tIns="0" rIns="0" bIns="0" rtlCol="0" anchor="t"/>
-          <a:lstStyle/>
-          <a:p>
-            <a:pPr indent="0" marL="0">
-              <a:buNone/>
-            </a:pPr>
-            <a:r>
-              <a:rPr lang="en-US" sz="1400" b="1" dirty="0">
-                <a:solidFill>
-                  <a:schemeClr val="tx1"/>
-                </a:solidFill>
-              </a:rPr>
-              <a:t>Vapor (Swift): </a:t>
-            </a:r>
-            <a:pPr indent="0" marL="0">
-              <a:spcAft>
-                <a:spcPts val="1200"/>
-              </a:spcAft>
-              <a:buNone/>
-            </a:pPr>
-            <a:r>
-              <a:rPr lang="en-US" sz="1400" dirty="0">
-                <a:solidFill>
-                  <a:schemeClr val="tx1"/>
-                </a:solidFill>
-              </a:rPr>
-              <a:t>API, Leaf portal, live session view</a:t>
-            </a:r>
-            <a:endParaRPr lang="en-US" sz="1400" dirty="0"/>
-          </a:p>
-          <a:p>
-            <a:pPr indent="0" marL="0">
-              <a:buNone/>
-            </a:pPr>
-            <a:r>
-              <a:rPr lang="en-US" sz="1400" b="1" dirty="0">
-                <a:solidFill>
-                  <a:schemeClr val="tx1"/>
-                </a:solidFill>
-              </a:rPr>
-              <a:t>Fluent: </a:t>
-            </a:r>
-            <a:pPr indent="0" marL="0">
-              <a:spcAft>
-                <a:spcPts val="1200"/>
-              </a:spcAft>
-              <a:buNone/>
-            </a:pPr>
-            <a:r>
-              <a:rPr lang="en-US" sz="1400" dirty="0">
-                <a:solidFill>
-                  <a:schemeClr val="tx1"/>
-                </a:solidFill>
-              </a:rPr>
-              <a:t>SQLite, or TencentDB for PostgreSQL</a:t>
-            </a:r>
-            <a:endParaRPr lang="en-US" sz="1400" dirty="0"/>
-          </a:p>
-          <a:p>
-            <a:pPr indent="0" marL="0">
-              <a:buNone/>
-            </a:pPr>
-            <a:r>
-              <a:rPr lang="en-US" sz="1400" b="1" dirty="0">
-                <a:solidFill>
-                  <a:schemeClr val="tx1"/>
-                </a:solidFill>
-              </a:rPr>
-              <a:t>LaileCore: </a:t>
-            </a:r>
-            <a:pPr indent="0" marL="0">
-              <a:spcAft>
-                <a:spcPts val="1200"/>
-              </a:spcAft>
-              <a:buNone/>
-            </a:pPr>
-            <a:r>
-              <a:rPr lang="en-US" sz="1400" dirty="0">
-                <a:solidFill>
-                  <a:schemeClr val="tx1"/>
-                </a:solidFill>
-              </a:rPr>
-              <a:t>safety rules, programs, care notes and the session engine, shared by phone and server</a:t>
-            </a:r>
-            <a:endParaRPr lang="en-US" sz="1400" dirty="0"/>
-          </a:p>
-          <a:p>
-            <a:pPr indent="0" marL="0">
-              <a:buNone/>
-            </a:pPr>
-            <a:r>
-              <a:rPr lang="en-US" sz="1400" b="1" dirty="0">
-                <a:solidFill>
-                  <a:schemeClr val="tx1"/>
-                </a:solidFill>
-              </a:rPr>
-              <a:t>166 automated tests: </a:t>
-            </a:r>
-            <a:pPr indent="0" marL="0">
-              <a:spcAft>
-                <a:spcPts val="1200"/>
-              </a:spcAft>
-              <a:buNone/>
-            </a:pPr>
-            <a:r>
-              <a:rPr lang="en-US" sz="1400" dirty="0">
-                <a:solidFill>
-                  <a:schemeClr val="tx1"/>
-                </a:solidFill>
-              </a:rPr>
-              <a:t>127 core, 33 server, 6 web</a:t>
-            </a:r>
-            <a:endParaRPr lang="en-US" sz="1400" dirty="0"/>
-          </a:p>
-        </p:txBody>
-      </p:sp>
-      <p:sp>
-        <p:nvSpPr>
-          <p:cNvPr id="12" name="Links"/>
+          <p:cNvPr id="16" name="Step 3"/>
           <p:cNvSpPr/>
           <p:nvPr/>
         </p:nvSpPr>
         <p:spPr>
           <a:xfrm>
-            <a:off x="548640" y="5349240"/>
-            <a:ext cx="11064240" cy="685800"/>
-          </a:xfrm>
-          <a:prstGeom prst="roundRect">
-            <a:avLst>
-              <a:gd name="adj" fmla="val 16000"/>
-            </a:avLst>
+            <a:off x="8366760" y="2377440"/>
+            <a:ext cx="502920" cy="502920"/>
+          </a:xfrm>
+          <a:prstGeom prst="ellipse">
+            <a:avLst/>
           </a:prstGeom>
           <a:solidFill>
-            <a:schemeClr val="accent3"/>
+            <a:schemeClr val="accent1"/>
           </a:solidFill>
           <a:ln w="12700">
             <a:solidFill>
-              <a:schemeClr val="accent3"/>
+              <a:schemeClr val="accent1"/>
             </a:solidFill>
             <a:prstDash val="solid"/>
           </a:ln>
@@ -5020,14 +4610,14 @@
       </p:sp>
       <p:sp>
         <p:nvSpPr>
-          <p:cNvPr id="13" name="Text 11"/>
+          <p:cNvPr id="17" name="Text 15"/>
           <p:cNvSpPr txBox="1"/>
           <p:nvPr/>
         </p:nvSpPr>
         <p:spPr>
           <a:xfrm>
-            <a:off x="777240" y="5349240"/>
-            <a:ext cx="10607040" cy="685800"/>
+            <a:off x="8366760" y="2377440"/>
+            <a:ext cx="502920" cy="502920"/>
           </a:xfrm>
           <a:prstGeom prst="rect">
             <a:avLst/>
@@ -5039,29 +4629,154 @@
           <a:bodyPr wrap="square" lIns="0" tIns="0" rIns="0" bIns="0" rtlCol="0" anchor="ctr"/>
           <a:lstStyle/>
           <a:p>
+            <a:pPr algn="ctr" indent="0" marL="0">
+              <a:buNone/>
+            </a:pPr>
+            <a:r>
+              <a:rPr lang="en-US" sz="1800" b="1" dirty="0">
+                <a:solidFill>
+                  <a:schemeClr val="bg1"/>
+                </a:solidFill>
+              </a:rPr>
+              <a:t>3</a:t>
+            </a:r>
+            <a:endParaRPr lang="en-US" sz="1800" dirty="0"/>
+          </a:p>
+        </p:txBody>
+      </p:sp>
+      <p:sp>
+        <p:nvSpPr>
+          <p:cNvPr id="18" name="Text 16"/>
+          <p:cNvSpPr txBox="1"/>
+          <p:nvPr/>
+        </p:nvSpPr>
+        <p:spPr>
+          <a:xfrm>
+            <a:off x="9006840" y="2377440"/>
+            <a:ext cx="2423160" cy="502920"/>
+          </a:xfrm>
+          <a:prstGeom prst="rect">
+            <a:avLst/>
+          </a:prstGeom>
+          <a:noFill/>
+          <a:ln/>
+        </p:spPr>
+        <p:txBody>
+          <a:bodyPr wrap="square" lIns="0" tIns="0" rIns="0" bIns="0" rtlCol="0" anchor="ctr"/>
+          <a:lstStyle/>
+          <a:p>
             <a:pPr indent="0" marL="0">
               <a:buNone/>
             </a:pPr>
             <a:r>
-              <a:rPr lang="en-US" sz="1400" b="1" dirty="0">
+              <a:rPr lang="en-US" sz="1900" b="1" dirty="0">
+                <a:solidFill>
+                  <a:schemeClr val="tx1"/>
+                </a:solidFill>
+              </a:rPr>
+              <a:t>CLINICIAN BRIEF</a:t>
+            </a:r>
+            <a:endParaRPr lang="en-US" sz="1900" dirty="0"/>
+          </a:p>
+        </p:txBody>
+      </p:sp>
+      <p:sp>
+        <p:nvSpPr>
+          <p:cNvPr id="19" name="Text 17"/>
+          <p:cNvSpPr txBox="1"/>
+          <p:nvPr/>
+        </p:nvSpPr>
+        <p:spPr>
+          <a:xfrm>
+            <a:off x="8366760" y="3063240"/>
+            <a:ext cx="3017520" cy="1920240"/>
+          </a:xfrm>
+          <a:prstGeom prst="rect">
+            <a:avLst/>
+          </a:prstGeom>
+          <a:noFill/>
+          <a:ln/>
+        </p:spPr>
+        <p:txBody>
+          <a:bodyPr wrap="square" lIns="0" tIns="0" rIns="0" bIns="0" rtlCol="0" anchor="t"/>
+          <a:lstStyle/>
+          <a:p>
+            <a:pPr indent="0" marL="0">
+              <a:spcAft>
+                <a:spcPts val="1000"/>
+              </a:spcAft>
+              <a:buNone/>
+            </a:pPr>
+            <a:r>
+              <a:rPr lang="en-US" sz="1400" dirty="0">
+                <a:solidFill>
+                  <a:schemeClr val="tx1"/>
+                </a:solidFill>
+              </a:rPr>
+              <a:t>Sent: adherence, key measures with numbers, recent reports, care notes and pending approvals, all computed by code.</a:t>
+            </a:r>
+            <a:endParaRPr lang="en-US" sz="1400" dirty="0"/>
+          </a:p>
+          <a:p>
+            <a:pPr indent="0" marL="0">
+              <a:buNone/>
+            </a:pPr>
+            <a:r>
+              <a:rPr lang="en-US" sz="1400" dirty="0">
+                <a:solidFill>
+                  <a:schemeClr val="tx1"/>
+                </a:solidFill>
+              </a:rPr>
+              <a:t>Back: 4 to 6 lines for the physio, with what the knowledge base says is typical at this stage.</a:t>
+            </a:r>
+            <a:endParaRPr lang="en-US" sz="1400" dirty="0"/>
+          </a:p>
+        </p:txBody>
+      </p:sp>
+      <p:sp>
+        <p:nvSpPr>
+          <p:cNvPr id="20" name="Text 18"/>
+          <p:cNvSpPr txBox="1"/>
+          <p:nvPr/>
+        </p:nvSpPr>
+        <p:spPr>
+          <a:xfrm>
+            <a:off x="548640" y="5440680"/>
+            <a:ext cx="11064240" cy="548640"/>
+          </a:xfrm>
+          <a:prstGeom prst="rect">
+            <a:avLst/>
+          </a:prstGeom>
+          <a:noFill/>
+          <a:ln/>
+        </p:spPr>
+        <p:txBody>
+          <a:bodyPr wrap="square" lIns="0" tIns="0" rIns="0" bIns="0" rtlCol="0" anchor="ctr"/>
+          <a:lstStyle/>
+          <a:p>
+            <a:pPr indent="0" marL="0">
+              <a:buNone/>
+            </a:pPr>
+            <a:r>
+              <a:rPr lang="en-US" sz="1500" b="1" dirty="0">
                 <a:solidFill>
                   <a:schemeClr val="accent1"/>
                 </a:solidFill>
               </a:rPr>
-              <a:t>Try it: </a:t>
+              <a:t>One agent, three modes. </a:t>
             </a:r>
             <a:pPr indent="0" marL="0">
               <a:buNone/>
             </a:pPr>
             <a:r>
-              <a:rPr lang="en-US" sz="1400" dirty="0">
+              <a:rPr lang="en-US" sz="1500" dirty="0">
                 <a:solidFill>
                   <a:schemeClr val="tx1"/>
                 </a:solidFill>
               </a:rPr>
-              <a:t>web app 43-156-108-79.sslip.io/app   ·   iPhone testflight.apple.com/join/WuymKzUH   ·   source github.com/LimCharles/laile</a:t>
-            </a:r>
-            <a:endParaRPr lang="en-US" sz="1400" dirty="0"/>
+              <a:t>The server starts each message with its mode, and Lele's prompt on ADP has a section for each. The same knowledge base grounds all three.</a:t>
+            </a:r>
+            <a:endParaRPr lang="en-US" sz="1500" dirty="0"/>
           </a:p>
         </p:txBody>
       </p:sp>
@@ -5167,7 +4882,7 @@
                   <a:schemeClr val="tx1"/>
                 </a:solidFill>
               </a:rPr>
-              <a:t>Key design trade-offs</a:t>
+              <a:t>Built with</a:t>
             </a:r>
             <a:endParaRPr lang="en-US" sz="3200" dirty="0"/>
           </a:p>
@@ -5175,18 +4890,609 @@
       </p:sp>
       <p:sp>
         <p:nvSpPr>
-          <p:cNvPr id="3" name="Choice 1"/>
+          <p:cNvPr id="3" name="Column Tencent Cloud and tools"/>
           <p:cNvSpPr/>
           <p:nvPr/>
         </p:nvSpPr>
         <p:spPr>
           <a:xfrm>
             <a:off x="548640" y="1234440"/>
-            <a:ext cx="3383280" cy="822960"/>
+            <a:ext cx="3520440" cy="3840480"/>
           </a:xfrm>
           <a:prstGeom prst="roundRect">
             <a:avLst>
-              <a:gd name="adj" fmla="val 13333"/>
+              <a:gd name="adj" fmla="val 3896"/>
+            </a:avLst>
+          </a:prstGeom>
+          <a:solidFill>
+            <a:schemeClr val="bg2"/>
+          </a:solidFill>
+          <a:ln w="9525">
+            <a:solidFill>
+              <a:srgbClr val="E1E7E3"/>
+            </a:solidFill>
+            <a:prstDash val="solid"/>
+          </a:ln>
+        </p:spPr>
+      </p:sp>
+      <p:sp>
+        <p:nvSpPr>
+          <p:cNvPr id="4" name="Text 2"/>
+          <p:cNvSpPr txBox="1"/>
+          <p:nvPr/>
+        </p:nvSpPr>
+        <p:spPr>
+          <a:xfrm>
+            <a:off x="822960" y="1417320"/>
+            <a:ext cx="3017520" cy="457200"/>
+          </a:xfrm>
+          <a:prstGeom prst="rect">
+            <a:avLst/>
+          </a:prstGeom>
+          <a:noFill/>
+          <a:ln/>
+        </p:spPr>
+        <p:txBody>
+          <a:bodyPr wrap="square" lIns="0" tIns="0" rIns="0" bIns="0" rtlCol="0" anchor="ctr"/>
+          <a:lstStyle/>
+          <a:p>
+            <a:pPr indent="0" marL="0">
+              <a:buNone/>
+            </a:pPr>
+            <a:r>
+              <a:rPr lang="en-US" sz="1800" b="1" dirty="0">
+                <a:solidFill>
+                  <a:schemeClr val="accent1"/>
+                </a:solidFill>
+              </a:rPr>
+              <a:t>Tencent Cloud and tools</a:t>
+            </a:r>
+            <a:endParaRPr lang="en-US" sz="1800" dirty="0"/>
+          </a:p>
+        </p:txBody>
+      </p:sp>
+      <p:sp>
+        <p:nvSpPr>
+          <p:cNvPr id="5" name="Text 3"/>
+          <p:cNvSpPr txBox="1"/>
+          <p:nvPr/>
+        </p:nvSpPr>
+        <p:spPr>
+          <a:xfrm>
+            <a:off x="822960" y="2011680"/>
+            <a:ext cx="3017520" cy="2926080"/>
+          </a:xfrm>
+          <a:prstGeom prst="rect">
+            <a:avLst/>
+          </a:prstGeom>
+          <a:noFill/>
+          <a:ln/>
+        </p:spPr>
+        <p:txBody>
+          <a:bodyPr wrap="square" lIns="0" tIns="0" rIns="0" bIns="0" rtlCol="0" anchor="t"/>
+          <a:lstStyle/>
+          <a:p>
+            <a:pPr indent="0" marL="0">
+              <a:buNone/>
+            </a:pPr>
+            <a:r>
+              <a:rPr lang="en-US" sz="1400" b="1" dirty="0">
+                <a:solidFill>
+                  <a:schemeClr val="tx1"/>
+                </a:solidFill>
+              </a:rPr>
+              <a:t>ADP: </a:t>
+            </a:r>
+            <a:pPr indent="0" marL="0">
+              <a:spcAft>
+                <a:spcPts val="1200"/>
+              </a:spcAft>
+              <a:buNone/>
+            </a:pPr>
+            <a:r>
+              <a:rPr lang="en-US" sz="1400" dirty="0">
+                <a:solidFill>
+                  <a:schemeClr val="tx1"/>
+                </a:solidFill>
+              </a:rPr>
+              <a:t>Lele on the Hy3 model with a 12-document knowledge base: chat, program drafts, the physio's summary</a:t>
+            </a:r>
+            <a:endParaRPr lang="en-US" sz="1400" dirty="0"/>
+          </a:p>
+          <a:p>
+            <a:pPr indent="0" marL="0">
+              <a:buNone/>
+            </a:pPr>
+            <a:r>
+              <a:rPr lang="en-US" sz="1400" b="1" dirty="0">
+                <a:solidFill>
+                  <a:schemeClr val="tx1"/>
+                </a:solidFill>
+              </a:rPr>
+              <a:t>Lighthouse: </a:t>
+            </a:r>
+            <a:pPr indent="0" marL="0">
+              <a:spcAft>
+                <a:spcPts val="1200"/>
+              </a:spcAft>
+              <a:buNone/>
+            </a:pPr>
+            <a:r>
+              <a:rPr lang="en-US" sz="1400" dirty="0">
+                <a:solidFill>
+                  <a:schemeClr val="tx1"/>
+                </a:solidFill>
+              </a:rPr>
+              <a:t>the server, web app and clinician portal (Docker, Caddy, HTTPS)</a:t>
+            </a:r>
+            <a:endParaRPr lang="en-US" sz="1400" dirty="0"/>
+          </a:p>
+          <a:p>
+            <a:pPr indent="0" marL="0">
+              <a:buNone/>
+            </a:pPr>
+            <a:r>
+              <a:rPr lang="en-US" sz="1400" b="1" dirty="0">
+                <a:solidFill>
+                  <a:schemeClr val="tx1"/>
+                </a:solidFill>
+              </a:rPr>
+              <a:t>CodeBuddy / WorkBuddy: </a:t>
+            </a:r>
+            <a:pPr indent="0" marL="0">
+              <a:spcAft>
+                <a:spcPts val="1200"/>
+              </a:spcAft>
+              <a:buNone/>
+            </a:pPr>
+            <a:r>
+              <a:rPr lang="en-US" sz="1400" dirty="0">
+                <a:solidFill>
+                  <a:schemeClr val="tx1"/>
+                </a:solidFill>
+              </a:rPr>
+              <a:t>safety and ADP audits; fixes reviewed and merged</a:t>
+            </a:r>
+            <a:endParaRPr lang="en-US" sz="1400" dirty="0"/>
+          </a:p>
+          <a:p>
+            <a:pPr indent="0" marL="0">
+              <a:buNone/>
+            </a:pPr>
+            <a:r>
+              <a:rPr lang="en-US" sz="1400" b="1" dirty="0">
+                <a:solidFill>
+                  <a:schemeClr val="tx1"/>
+                </a:solidFill>
+              </a:rPr>
+              <a:t>Miora: </a:t>
+            </a:r>
+            <a:pPr indent="0" marL="0">
+              <a:spcAft>
+                <a:spcPts val="1200"/>
+              </a:spcAft>
+              <a:buNone/>
+            </a:pPr>
+            <a:r>
+              <a:rPr lang="en-US" sz="1400" dirty="0">
+                <a:solidFill>
+                  <a:schemeClr val="tx1"/>
+                </a:solidFill>
+              </a:rPr>
+              <a:t>logo, cover, app icon and the Lele mascot</a:t>
+            </a:r>
+            <a:endParaRPr lang="en-US" sz="1400" dirty="0"/>
+          </a:p>
+        </p:txBody>
+      </p:sp>
+      <p:sp>
+        <p:nvSpPr>
+          <p:cNvPr id="6" name="Column iPhone and web apps"/>
+          <p:cNvSpPr/>
+          <p:nvPr/>
+        </p:nvSpPr>
+        <p:spPr>
+          <a:xfrm>
+            <a:off x="4320540" y="1234440"/>
+            <a:ext cx="3520440" cy="3840480"/>
+          </a:xfrm>
+          <a:prstGeom prst="roundRect">
+            <a:avLst>
+              <a:gd name="adj" fmla="val 3896"/>
+            </a:avLst>
+          </a:prstGeom>
+          <a:solidFill>
+            <a:schemeClr val="bg2"/>
+          </a:solidFill>
+          <a:ln w="9525">
+            <a:solidFill>
+              <a:srgbClr val="E1E7E3"/>
+            </a:solidFill>
+            <a:prstDash val="solid"/>
+          </a:ln>
+        </p:spPr>
+      </p:sp>
+      <p:sp>
+        <p:nvSpPr>
+          <p:cNvPr id="7" name="Text 5"/>
+          <p:cNvSpPr txBox="1"/>
+          <p:nvPr/>
+        </p:nvSpPr>
+        <p:spPr>
+          <a:xfrm>
+            <a:off x="4594860" y="1417320"/>
+            <a:ext cx="3017520" cy="457200"/>
+          </a:xfrm>
+          <a:prstGeom prst="rect">
+            <a:avLst/>
+          </a:prstGeom>
+          <a:noFill/>
+          <a:ln/>
+        </p:spPr>
+        <p:txBody>
+          <a:bodyPr wrap="square" lIns="0" tIns="0" rIns="0" bIns="0" rtlCol="0" anchor="ctr"/>
+          <a:lstStyle/>
+          <a:p>
+            <a:pPr indent="0" marL="0">
+              <a:buNone/>
+            </a:pPr>
+            <a:r>
+              <a:rPr lang="en-US" sz="1800" b="1" dirty="0">
+                <a:solidFill>
+                  <a:schemeClr val="tx1"/>
+                </a:solidFill>
+              </a:rPr>
+              <a:t>iPhone and web apps</a:t>
+            </a:r>
+            <a:endParaRPr lang="en-US" sz="1800" dirty="0"/>
+          </a:p>
+        </p:txBody>
+      </p:sp>
+      <p:sp>
+        <p:nvSpPr>
+          <p:cNvPr id="8" name="Text 6"/>
+          <p:cNvSpPr txBox="1"/>
+          <p:nvPr/>
+        </p:nvSpPr>
+        <p:spPr>
+          <a:xfrm>
+            <a:off x="4594860" y="2011680"/>
+            <a:ext cx="3017520" cy="2926080"/>
+          </a:xfrm>
+          <a:prstGeom prst="rect">
+            <a:avLst/>
+          </a:prstGeom>
+          <a:noFill/>
+          <a:ln/>
+        </p:spPr>
+        <p:txBody>
+          <a:bodyPr wrap="square" lIns="0" tIns="0" rIns="0" bIns="0" rtlCol="0" anchor="t"/>
+          <a:lstStyle/>
+          <a:p>
+            <a:pPr indent="0" marL="0">
+              <a:buNone/>
+            </a:pPr>
+            <a:r>
+              <a:rPr lang="en-US" sz="1400" b="1" dirty="0">
+                <a:solidFill>
+                  <a:schemeClr val="tx1"/>
+                </a:solidFill>
+              </a:rPr>
+              <a:t>Swift 6, SwiftUI: </a:t>
+            </a:r>
+            <a:pPr indent="0" marL="0">
+              <a:spcAft>
+                <a:spcPts val="1200"/>
+              </a:spcAft>
+              <a:buNone/>
+            </a:pPr>
+            <a:r>
+              <a:rPr lang="en-US" sz="1400" dirty="0">
+                <a:solidFill>
+                  <a:schemeClr val="tx1"/>
+                </a:solidFill>
+              </a:rPr>
+              <a:t>feature modules in LaileKit</a:t>
+            </a:r>
+            <a:endParaRPr lang="en-US" sz="1400" dirty="0"/>
+          </a:p>
+          <a:p>
+            <a:pPr indent="0" marL="0">
+              <a:buNone/>
+            </a:pPr>
+            <a:r>
+              <a:rPr lang="en-US" sz="1400" b="1" dirty="0">
+                <a:solidFill>
+                  <a:schemeClr val="tx1"/>
+                </a:solidFill>
+              </a:rPr>
+              <a:t>Apple Vision, Speech: </a:t>
+            </a:r>
+            <a:pPr indent="0" marL="0">
+              <a:spcAft>
+                <a:spcPts val="1200"/>
+              </a:spcAft>
+              <a:buNone/>
+            </a:pPr>
+            <a:r>
+              <a:rPr lang="en-US" sz="1400" dirty="0">
+                <a:solidFill>
+                  <a:schemeClr val="tx1"/>
+                </a:solidFill>
+              </a:rPr>
+              <a:t>body pose for reps, holds and angles; spoken symptoms</a:t>
+            </a:r>
+            <a:endParaRPr lang="en-US" sz="1400" dirty="0"/>
+          </a:p>
+          <a:p>
+            <a:pPr indent="0" marL="0">
+              <a:buNone/>
+            </a:pPr>
+            <a:r>
+              <a:rPr lang="en-US" sz="1400" b="1" dirty="0">
+                <a:solidFill>
+                  <a:schemeClr val="tx1"/>
+                </a:solidFill>
+              </a:rPr>
+              <a:t>Web app: </a:t>
+            </a:r>
+            <a:pPr indent="0" marL="0">
+              <a:spcAft>
+                <a:spcPts val="1200"/>
+              </a:spcAft>
+              <a:buNone/>
+            </a:pPr>
+            <a:r>
+              <a:rPr lang="en-US" sz="1400" dirty="0">
+                <a:solidFill>
+                  <a:schemeClr val="tx1"/>
+                </a:solidFill>
+              </a:rPr>
+              <a:t>plain JavaScript, MediaPipe pose, the same API</a:t>
+            </a:r>
+            <a:endParaRPr lang="en-US" sz="1400" dirty="0"/>
+          </a:p>
+          <a:p>
+            <a:pPr indent="0" marL="0">
+              <a:buNone/>
+            </a:pPr>
+            <a:r>
+              <a:rPr lang="en-US" sz="1400" b="1" dirty="0">
+                <a:solidFill>
+                  <a:schemeClr val="tx1"/>
+                </a:solidFill>
+              </a:rPr>
+              <a:t>ElevenLabs: </a:t>
+            </a:r>
+            <a:pPr indent="0" marL="0">
+              <a:spcAft>
+                <a:spcPts val="1200"/>
+              </a:spcAft>
+              <a:buNone/>
+            </a:pPr>
+            <a:r>
+              <a:rPr lang="en-US" sz="1400" dirty="0">
+                <a:solidFill>
+                  <a:schemeClr val="tx1"/>
+                </a:solidFill>
+              </a:rPr>
+              <a:t>Lele's voice on phone and web, cached per line</a:t>
+            </a:r>
+            <a:endParaRPr lang="en-US" sz="1400" dirty="0"/>
+          </a:p>
+        </p:txBody>
+      </p:sp>
+      <p:sp>
+        <p:nvSpPr>
+          <p:cNvPr id="9" name="Column Server and shared code"/>
+          <p:cNvSpPr/>
+          <p:nvPr/>
+        </p:nvSpPr>
+        <p:spPr>
+          <a:xfrm>
+            <a:off x="8092440" y="1234440"/>
+            <a:ext cx="3520440" cy="3840480"/>
+          </a:xfrm>
+          <a:prstGeom prst="roundRect">
+            <a:avLst>
+              <a:gd name="adj" fmla="val 3896"/>
+            </a:avLst>
+          </a:prstGeom>
+          <a:solidFill>
+            <a:schemeClr val="bg2"/>
+          </a:solidFill>
+          <a:ln w="9525">
+            <a:solidFill>
+              <a:srgbClr val="E1E7E3"/>
+            </a:solidFill>
+            <a:prstDash val="solid"/>
+          </a:ln>
+        </p:spPr>
+      </p:sp>
+      <p:sp>
+        <p:nvSpPr>
+          <p:cNvPr id="10" name="Text 8"/>
+          <p:cNvSpPr txBox="1"/>
+          <p:nvPr/>
+        </p:nvSpPr>
+        <p:spPr>
+          <a:xfrm>
+            <a:off x="8366760" y="1417320"/>
+            <a:ext cx="3017520" cy="457200"/>
+          </a:xfrm>
+          <a:prstGeom prst="rect">
+            <a:avLst/>
+          </a:prstGeom>
+          <a:noFill/>
+          <a:ln/>
+        </p:spPr>
+        <p:txBody>
+          <a:bodyPr wrap="square" lIns="0" tIns="0" rIns="0" bIns="0" rtlCol="0" anchor="ctr"/>
+          <a:lstStyle/>
+          <a:p>
+            <a:pPr indent="0" marL="0">
+              <a:buNone/>
+            </a:pPr>
+            <a:r>
+              <a:rPr lang="en-US" sz="1800" b="1" dirty="0">
+                <a:solidFill>
+                  <a:schemeClr val="accent2"/>
+                </a:solidFill>
+              </a:rPr>
+              <a:t>Server and shared code</a:t>
+            </a:r>
+            <a:endParaRPr lang="en-US" sz="1800" dirty="0"/>
+          </a:p>
+        </p:txBody>
+      </p:sp>
+      <p:sp>
+        <p:nvSpPr>
+          <p:cNvPr id="11" name="Text 9"/>
+          <p:cNvSpPr txBox="1"/>
+          <p:nvPr/>
+        </p:nvSpPr>
+        <p:spPr>
+          <a:xfrm>
+            <a:off x="8366760" y="2011680"/>
+            <a:ext cx="3017520" cy="2926080"/>
+          </a:xfrm>
+          <a:prstGeom prst="rect">
+            <a:avLst/>
+          </a:prstGeom>
+          <a:noFill/>
+          <a:ln/>
+        </p:spPr>
+        <p:txBody>
+          <a:bodyPr wrap="square" lIns="0" tIns="0" rIns="0" bIns="0" rtlCol="0" anchor="t"/>
+          <a:lstStyle/>
+          <a:p>
+            <a:pPr indent="0" marL="0">
+              <a:buNone/>
+            </a:pPr>
+            <a:r>
+              <a:rPr lang="en-US" sz="1400" b="1" dirty="0">
+                <a:solidFill>
+                  <a:schemeClr val="tx1"/>
+                </a:solidFill>
+              </a:rPr>
+              <a:t>Vapor (Swift): </a:t>
+            </a:r>
+            <a:pPr indent="0" marL="0">
+              <a:spcAft>
+                <a:spcPts val="1200"/>
+              </a:spcAft>
+              <a:buNone/>
+            </a:pPr>
+            <a:r>
+              <a:rPr lang="en-US" sz="1400" dirty="0">
+                <a:solidFill>
+                  <a:schemeClr val="tx1"/>
+                </a:solidFill>
+              </a:rPr>
+              <a:t>API, Leaf portal, live session view</a:t>
+            </a:r>
+            <a:endParaRPr lang="en-US" sz="1400" dirty="0"/>
+          </a:p>
+          <a:p>
+            <a:pPr indent="0" marL="0">
+              <a:buNone/>
+            </a:pPr>
+            <a:r>
+              <a:rPr lang="en-US" sz="1400" b="1" dirty="0">
+                <a:solidFill>
+                  <a:schemeClr val="tx1"/>
+                </a:solidFill>
+              </a:rPr>
+              <a:t>Fluent: </a:t>
+            </a:r>
+            <a:pPr indent="0" marL="0">
+              <a:spcAft>
+                <a:spcPts val="1200"/>
+              </a:spcAft>
+              <a:buNone/>
+            </a:pPr>
+            <a:r>
+              <a:rPr lang="en-US" sz="1400" dirty="0">
+                <a:solidFill>
+                  <a:schemeClr val="tx1"/>
+                </a:solidFill>
+              </a:rPr>
+              <a:t>SQLite, or TencentDB for PostgreSQL</a:t>
+            </a:r>
+            <a:endParaRPr lang="en-US" sz="1400" dirty="0"/>
+          </a:p>
+          <a:p>
+            <a:pPr indent="0" marL="0">
+              <a:buNone/>
+            </a:pPr>
+            <a:r>
+              <a:rPr lang="en-US" sz="1400" b="1" dirty="0">
+                <a:solidFill>
+                  <a:schemeClr val="tx1"/>
+                </a:solidFill>
+              </a:rPr>
+              <a:t>LaileCore: </a:t>
+            </a:r>
+            <a:pPr indent="0" marL="0">
+              <a:spcAft>
+                <a:spcPts val="1200"/>
+              </a:spcAft>
+              <a:buNone/>
+            </a:pPr>
+            <a:r>
+              <a:rPr lang="en-US" sz="1400" dirty="0">
+                <a:solidFill>
+                  <a:schemeClr val="tx1"/>
+                </a:solidFill>
+              </a:rPr>
+              <a:t>safety rules, programs, care notes and the session engine, shared by phone and server</a:t>
+            </a:r>
+            <a:endParaRPr lang="en-US" sz="1400" dirty="0"/>
+          </a:p>
+          <a:p>
+            <a:pPr indent="0" marL="0">
+              <a:buNone/>
+            </a:pPr>
+            <a:r>
+              <a:rPr lang="en-US" sz="1400" b="1" dirty="0">
+                <a:solidFill>
+                  <a:schemeClr val="tx1"/>
+                </a:solidFill>
+              </a:rPr>
+              <a:t>166 automated tests: </a:t>
+            </a:r>
+            <a:pPr indent="0" marL="0">
+              <a:spcAft>
+                <a:spcPts val="1200"/>
+              </a:spcAft>
+              <a:buNone/>
+            </a:pPr>
+            <a:r>
+              <a:rPr lang="en-US" sz="1400" dirty="0">
+                <a:solidFill>
+                  <a:schemeClr val="tx1"/>
+                </a:solidFill>
+              </a:rPr>
+              <a:t>127 core, 33 server, 6 web</a:t>
+            </a:r>
+            <a:endParaRPr lang="en-US" sz="1400" dirty="0"/>
+          </a:p>
+        </p:txBody>
+      </p:sp>
+      <p:sp>
+        <p:nvSpPr>
+          <p:cNvPr id="12" name="Links"/>
+          <p:cNvSpPr/>
+          <p:nvPr/>
+        </p:nvSpPr>
+        <p:spPr>
+          <a:xfrm>
+            <a:off x="548640" y="5349240"/>
+            <a:ext cx="11064240" cy="685800"/>
+          </a:xfrm>
+          <a:prstGeom prst="roundRect">
+            <a:avLst>
+              <a:gd name="adj" fmla="val 16000"/>
             </a:avLst>
           </a:prstGeom>
           <a:solidFill>
@@ -5202,14 +5508,14 @@
       </p:sp>
       <p:sp>
         <p:nvSpPr>
-          <p:cNvPr id="4" name="Text 2"/>
+          <p:cNvPr id="13" name="Text 11"/>
           <p:cNvSpPr txBox="1"/>
           <p:nvPr/>
         </p:nvSpPr>
         <p:spPr>
           <a:xfrm>
-            <a:off x="731520" y="1234440"/>
-            <a:ext cx="3017520" cy="822960"/>
+            <a:off x="777240" y="5349240"/>
+            <a:ext cx="10607040" cy="685800"/>
           </a:xfrm>
           <a:prstGeom prst="rect">
             <a:avLst/>
@@ -5225,27 +5531,110 @@
               <a:buNone/>
             </a:pPr>
             <a:r>
-              <a:rPr lang="en-US" sz="1500" b="1" dirty="0">
+              <a:rPr lang="en-US" sz="1400" b="1" dirty="0">
                 <a:solidFill>
                   <a:schemeClr val="accent1"/>
                 </a:solidFill>
               </a:rPr>
-              <a:t>Native iPhone app, web app, Swift server</a:t>
-            </a:r>
-            <a:endParaRPr lang="en-US" sz="1500" dirty="0"/>
-          </a:p>
-        </p:txBody>
-      </p:sp>
-      <p:sp>
-        <p:nvSpPr>
-          <p:cNvPr id="5" name="Text 3"/>
-          <p:cNvSpPr txBox="1"/>
-          <p:nvPr/>
-        </p:nvSpPr>
-        <p:spPr>
-          <a:xfrm>
-            <a:off x="4206240" y="1234440"/>
-            <a:ext cx="7406640" cy="822960"/>
+              <a:t>Try it: </a:t>
+            </a:r>
+            <a:pPr indent="0" marL="0">
+              <a:buNone/>
+            </a:pPr>
+            <a:r>
+              <a:rPr lang="en-US" sz="1400" dirty="0">
+                <a:solidFill>
+                  <a:schemeClr val="tx1"/>
+                </a:solidFill>
+              </a:rPr>
+              <a:t>web app 43-156-108-79.sslip.io/app   ·   iPhone testflight.apple.com/join/WuymKzUH   ·   source github.com/LimCharles/laile</a:t>
+            </a:r>
+            <a:endParaRPr lang="en-US" sz="1400" dirty="0"/>
+          </a:p>
+        </p:txBody>
+      </p:sp>
+      <p:sp>
+        <p:nvSpPr>
+          <p:cNvPr id="25" name="Slide Number Placeholder 0"/>
+          <p:cNvSpPr>
+            <a:spLocks noGrp="1"/>
+          </p:cNvSpPr>
+          <p:nvPr>
+            <p:ph type="sldNum" sz="quarter" idx="4294967295"/>
+          </p:nvPr>
+        </p:nvSpPr>
+        <p:spPr>
+          <a:xfrm>
+            <a:off x="11155680" y="6400800"/>
+            <a:ext cx="457200" cy="274320"/>
+          </a:xfrm>
+          <a:prstGeom prst="rect">
+            <a:avLst/>
+          </a:prstGeom>
+          <a:extLst>
+            <a:ext uri="{C572A759-6A51-4108-AA02-DFA0A04FC94B}">
+              <ma14:wrappingTextBoxFlag xmlns:ma14="http://schemas.microsoft.com/office/mac/drawingml/2011/main" val="0"/>
+            </a:ext>
+          </a:extLst>
+        </p:spPr>
+        <p:txBody>
+          <a:bodyPr/>
+          <a:lstStyle>
+            <a:lvl1pPr>
+              <a:defRPr sz="1000">
+                <a:solidFill>
+                  <a:schemeClr val="accent4"/>
+                </a:solidFill>
+              </a:defRPr>
+            </a:lvl1pPr>
+          </a:lstStyle>
+          <a:p>
+            <a:pPr algn="r"/>
+            <a:fld id="{F7021451-1387-4CA6-816F-3879F97B5CBC}" type="slidenum">
+              <a:rPr b="0" lang="en-US"/>
+              <a:t>6</a:t>
+            </a:fld>
+            <a:endParaRPr lang="en-US"/>
+          </a:p>
+        </p:txBody>
+      </p:sp>
+    </p:spTree>
+  </p:cSld>
+  <p:clrMapOvr>
+    <a:masterClrMapping/>
+  </p:clrMapOvr>
+</p:sld>
+</file>
+
+<file path=ppt/slides/slide7.xml><?xml version="1.0" encoding="utf-8"?>
+<p:sld xmlns:a="http://schemas.openxmlformats.org/drawingml/2006/main" xmlns:r="http://schemas.openxmlformats.org/officeDocument/2006/relationships" xmlns:p="http://schemas.openxmlformats.org/presentationml/2006/main">
+  <p:cSld name="Slide 7">
+    <p:spTree>
+      <p:nvGrpSpPr>
+        <p:cNvPr id="1" name=""/>
+        <p:cNvGrpSpPr/>
+        <p:nvPr/>
+      </p:nvGrpSpPr>
+      <p:grpSpPr>
+        <a:xfrm>
+          <a:off x="0" y="0"/>
+          <a:ext cx="0" cy="0"/>
+          <a:chOff x="0" y="0"/>
+          <a:chExt cx="0" cy="0"/>
+        </a:xfrm>
+      </p:grpSpPr>
+      <p:sp>
+        <p:nvSpPr>
+          <p:cNvPr id="2" name="Text 0"/>
+          <p:cNvSpPr/>
+          <p:nvPr>
+            <p:ph idx="100" type="title" hasCustomPrompt="1"/>
+          </p:nvPr>
+        </p:nvSpPr>
+        <p:spPr>
+          <a:xfrm>
+            <a:off x="548640" y="320040"/>
+            <a:ext cx="11064240" cy="731520"/>
           </a:xfrm>
           <a:prstGeom prst="rect">
             <a:avLst/>
@@ -5257,30 +5646,30 @@
           <a:bodyPr wrap="square" lIns="0" tIns="0" rIns="0" bIns="0" rtlCol="0" anchor="ctr"/>
           <a:lstStyle/>
           <a:p>
-            <a:pPr indent="0" marL="0">
-              <a:buNone/>
-            </a:pPr>
-            <a:r>
-              <a:rPr lang="en-US" sz="1400" dirty="0">
+            <a:pPr algn="l" indent="0" marL="0">
+              <a:buNone/>
+            </a:pPr>
+            <a:r>
+              <a:rPr lang="en-US" sz="3200" b="1" dirty="0">
                 <a:solidFill>
                   <a:schemeClr val="tx1"/>
                 </a:solidFill>
               </a:rPr>
-              <a:t>Native camera performance and one language for the shared logic. The web app covers Android and laptops; its session engine is a JavaScript port tested against the same plan.</a:t>
-            </a:r>
-            <a:endParaRPr lang="en-US" sz="1400" dirty="0"/>
-          </a:p>
-        </p:txBody>
-      </p:sp>
-      <p:sp>
-        <p:nvSpPr>
-          <p:cNvPr id="6" name="Choice 2"/>
+              <a:t>Key design trade-offs</a:t>
+            </a:r>
+            <a:endParaRPr lang="en-US" sz="3200" dirty="0"/>
+          </a:p>
+        </p:txBody>
+      </p:sp>
+      <p:sp>
+        <p:nvSpPr>
+          <p:cNvPr id="3" name="Choice 1"/>
           <p:cNvSpPr/>
           <p:nvPr/>
         </p:nvSpPr>
         <p:spPr>
           <a:xfrm>
-            <a:off x="548640" y="2212848"/>
+            <a:off x="548640" y="1234440"/>
             <a:ext cx="3383280" cy="822960"/>
           </a:xfrm>
           <a:prstGeom prst="roundRect">
@@ -5301,13 +5690,13 @@
       </p:sp>
       <p:sp>
         <p:nvSpPr>
-          <p:cNvPr id="7" name="Text 5"/>
+          <p:cNvPr id="4" name="Text 2"/>
           <p:cNvSpPr txBox="1"/>
           <p:nvPr/>
         </p:nvSpPr>
         <p:spPr>
           <a:xfrm>
-            <a:off x="731520" y="2212848"/>
+            <a:off x="731520" y="1234440"/>
             <a:ext cx="3017520" cy="822960"/>
           </a:xfrm>
           <a:prstGeom prst="rect">
@@ -5329,7 +5718,7 @@
                   <a:schemeClr val="accent1"/>
                 </a:solidFill>
               </a:rPr>
-              <a:t>Pose on the device</a:t>
+              <a:t>Native iPhone app, web app, Swift server</a:t>
             </a:r>
             <a:endParaRPr lang="en-US" sz="1500" dirty="0"/>
           </a:p>
@@ -5337,13 +5726,13 @@
       </p:sp>
       <p:sp>
         <p:nvSpPr>
-          <p:cNvPr id="8" name="Text 6"/>
+          <p:cNvPr id="5" name="Text 3"/>
           <p:cNvSpPr txBox="1"/>
           <p:nvPr/>
         </p:nvSpPr>
         <p:spPr>
           <a:xfrm>
-            <a:off x="4206240" y="2212848"/>
+            <a:off x="4206240" y="1234440"/>
             <a:ext cx="7406640" cy="822960"/>
           </a:xfrm>
           <a:prstGeom prst="rect">
@@ -5365,7 +5754,7 @@
                   <a:schemeClr val="tx1"/>
                 </a:solidFill>
               </a:rPr>
-              <a:t>No video upload, and the iPhone works offline. Joints are 2D, so angles are estimates for tracking trends, and reports say so.</a:t>
+              <a:t>Native camera performance and one language for the shared logic. The web app covers Android and laptops; its session engine is a JavaScript port tested against the same plan.</a:t>
             </a:r>
             <a:endParaRPr lang="en-US" sz="1400" dirty="0"/>
           </a:p>
@@ -5373,13 +5762,13 @@
       </p:sp>
       <p:sp>
         <p:nvSpPr>
-          <p:cNvPr id="9" name="Choice 3"/>
+          <p:cNvPr id="6" name="Choice 2"/>
           <p:cNvSpPr/>
           <p:nvPr/>
         </p:nvSpPr>
         <p:spPr>
           <a:xfrm>
-            <a:off x="548640" y="3191256"/>
+            <a:off x="548640" y="2212848"/>
             <a:ext cx="3383280" cy="822960"/>
           </a:xfrm>
           <a:prstGeom prst="roundRect">
@@ -5400,13 +5789,13 @@
       </p:sp>
       <p:sp>
         <p:nvSpPr>
-          <p:cNvPr id="10" name="Text 8"/>
+          <p:cNvPr id="7" name="Text 5"/>
           <p:cNvSpPr txBox="1"/>
           <p:nvPr/>
         </p:nvSpPr>
         <p:spPr>
           <a:xfrm>
-            <a:off x="731520" y="3191256"/>
+            <a:off x="731520" y="2212848"/>
             <a:ext cx="3017520" cy="822960"/>
           </a:xfrm>
           <a:prstGeom prst="rect">
@@ -5428,7 +5817,7 @@
                   <a:schemeClr val="accent1"/>
                 </a:solidFill>
               </a:rPr>
-              <a:t>Rules for safety, a model for talk</a:t>
+              <a:t>Pose on the device</a:t>
             </a:r>
             <a:endParaRPr lang="en-US" sz="1500" dirty="0"/>
           </a:p>
@@ -5436,13 +5825,13 @@
       </p:sp>
       <p:sp>
         <p:nvSpPr>
-          <p:cNvPr id="11" name="Text 9"/>
+          <p:cNvPr id="8" name="Text 6"/>
           <p:cNvSpPr txBox="1"/>
           <p:nvPr/>
         </p:nvSpPr>
         <p:spPr>
           <a:xfrm>
-            <a:off x="4206240" y="3191256"/>
+            <a:off x="4206240" y="2212848"/>
             <a:ext cx="7406640" cy="822960"/>
           </a:xfrm>
           <a:prstGeom prst="rect">
@@ -5464,7 +5853,7 @@
                   <a:schemeClr val="tx1"/>
                 </a:solidFill>
               </a:rPr>
-              <a:t>Predictable, testable safety. Unusual phrasings fall back to a clarifying question instead of a guess.</a:t>
+              <a:t>No video upload, and the iPhone works offline. Joints are 2D, so angles are estimates for tracking trends, and reports say so.</a:t>
             </a:r>
             <a:endParaRPr lang="en-US" sz="1400" dirty="0"/>
           </a:p>
@@ -5472,13 +5861,13 @@
       </p:sp>
       <p:sp>
         <p:nvSpPr>
-          <p:cNvPr id="12" name="Choice 4"/>
+          <p:cNvPr id="9" name="Choice 3"/>
           <p:cNvSpPr/>
           <p:nvPr/>
         </p:nvSpPr>
         <p:spPr>
           <a:xfrm>
-            <a:off x="548640" y="4169664"/>
+            <a:off x="548640" y="3191256"/>
             <a:ext cx="3383280" cy="822960"/>
           </a:xfrm>
           <a:prstGeom prst="roundRect">
@@ -5499,13 +5888,13 @@
       </p:sp>
       <p:sp>
         <p:nvSpPr>
-          <p:cNvPr id="13" name="Text 11"/>
+          <p:cNvPr id="10" name="Text 8"/>
           <p:cNvSpPr txBox="1"/>
           <p:nvPr/>
         </p:nvSpPr>
         <p:spPr>
           <a:xfrm>
-            <a:off x="731520" y="4169664"/>
+            <a:off x="731520" y="3191256"/>
             <a:ext cx="3017520" cy="822960"/>
           </a:xfrm>
           <a:prstGeom prst="rect">
@@ -5527,7 +5916,7 @@
                   <a:schemeClr val="accent1"/>
                 </a:solidFill>
               </a:rPr>
-              <a:t>ADP knowledge base</a:t>
+              <a:t>Rules for safety, a model for talk</a:t>
             </a:r>
             <a:endParaRPr lang="en-US" sz="1500" dirty="0"/>
           </a:p>
@@ -5535,13 +5924,13 @@
       </p:sp>
       <p:sp>
         <p:nvSpPr>
-          <p:cNvPr id="14" name="Text 12"/>
+          <p:cNvPr id="11" name="Text 9"/>
           <p:cNvSpPr txBox="1"/>
           <p:nvPr/>
         </p:nvSpPr>
         <p:spPr>
           <a:xfrm>
-            <a:off x="4206240" y="4169664"/>
+            <a:off x="4206240" y="3191256"/>
             <a:ext cx="7406640" cy="822960"/>
           </a:xfrm>
           <a:prstGeom prst="rect">
@@ -5563,7 +5952,7 @@
                   <a:schemeClr val="tx1"/>
                 </a:solidFill>
               </a:rPr>
-              <a:t>Curated, reviewable content. Its answer template can override the persona, so each message restates Lele's voice and replies are tidied.</a:t>
+              <a:t>Predictable, testable safety. Unusual phrasings fall back to a clarifying question instead of a guess.</a:t>
             </a:r>
             <a:endParaRPr lang="en-US" sz="1400" dirty="0"/>
           </a:p>
@@ -5571,13 +5960,13 @@
       </p:sp>
       <p:sp>
         <p:nvSpPr>
-          <p:cNvPr id="15" name="Choice 5"/>
+          <p:cNvPr id="12" name="Choice 4"/>
           <p:cNvSpPr/>
           <p:nvPr/>
         </p:nvSpPr>
         <p:spPr>
           <a:xfrm>
-            <a:off x="548640" y="5148072"/>
+            <a:off x="548640" y="4169664"/>
             <a:ext cx="3383280" cy="822960"/>
           </a:xfrm>
           <a:prstGeom prst="roundRect">
@@ -5598,6 +5987,105 @@
       </p:sp>
       <p:sp>
         <p:nvSpPr>
+          <p:cNvPr id="13" name="Text 11"/>
+          <p:cNvSpPr txBox="1"/>
+          <p:nvPr/>
+        </p:nvSpPr>
+        <p:spPr>
+          <a:xfrm>
+            <a:off x="731520" y="4169664"/>
+            <a:ext cx="3017520" cy="822960"/>
+          </a:xfrm>
+          <a:prstGeom prst="rect">
+            <a:avLst/>
+          </a:prstGeom>
+          <a:noFill/>
+          <a:ln/>
+        </p:spPr>
+        <p:txBody>
+          <a:bodyPr wrap="square" lIns="0" tIns="0" rIns="0" bIns="0" rtlCol="0" anchor="ctr"/>
+          <a:lstStyle/>
+          <a:p>
+            <a:pPr indent="0" marL="0">
+              <a:buNone/>
+            </a:pPr>
+            <a:r>
+              <a:rPr lang="en-US" sz="1500" b="1" dirty="0">
+                <a:solidFill>
+                  <a:schemeClr val="accent1"/>
+                </a:solidFill>
+              </a:rPr>
+              <a:t>ADP knowledge base</a:t>
+            </a:r>
+            <a:endParaRPr lang="en-US" sz="1500" dirty="0"/>
+          </a:p>
+        </p:txBody>
+      </p:sp>
+      <p:sp>
+        <p:nvSpPr>
+          <p:cNvPr id="14" name="Text 12"/>
+          <p:cNvSpPr txBox="1"/>
+          <p:nvPr/>
+        </p:nvSpPr>
+        <p:spPr>
+          <a:xfrm>
+            <a:off x="4206240" y="4169664"/>
+            <a:ext cx="7406640" cy="822960"/>
+          </a:xfrm>
+          <a:prstGeom prst="rect">
+            <a:avLst/>
+          </a:prstGeom>
+          <a:noFill/>
+          <a:ln/>
+        </p:spPr>
+        <p:txBody>
+          <a:bodyPr wrap="square" lIns="0" tIns="0" rIns="0" bIns="0" rtlCol="0" anchor="ctr"/>
+          <a:lstStyle/>
+          <a:p>
+            <a:pPr indent="0" marL="0">
+              <a:buNone/>
+            </a:pPr>
+            <a:r>
+              <a:rPr lang="en-US" sz="1400" dirty="0">
+                <a:solidFill>
+                  <a:schemeClr val="tx1"/>
+                </a:solidFill>
+              </a:rPr>
+              <a:t>Curated, reviewable content. Its answer template can override the persona, so each message restates Lele's voice and replies are tidied.</a:t>
+            </a:r>
+            <a:endParaRPr lang="en-US" sz="1400" dirty="0"/>
+          </a:p>
+        </p:txBody>
+      </p:sp>
+      <p:sp>
+        <p:nvSpPr>
+          <p:cNvPr id="15" name="Choice 5"/>
+          <p:cNvSpPr/>
+          <p:nvPr/>
+        </p:nvSpPr>
+        <p:spPr>
+          <a:xfrm>
+            <a:off x="548640" y="5148072"/>
+            <a:ext cx="3383280" cy="822960"/>
+          </a:xfrm>
+          <a:prstGeom prst="roundRect">
+            <a:avLst>
+              <a:gd name="adj" fmla="val 13333"/>
+            </a:avLst>
+          </a:prstGeom>
+          <a:solidFill>
+            <a:schemeClr val="accent3"/>
+          </a:solidFill>
+          <a:ln w="12700">
+            <a:solidFill>
+              <a:schemeClr val="accent3"/>
+            </a:solidFill>
+            <a:prstDash val="solid"/>
+          </a:ln>
+        </p:spPr>
+      </p:sp>
+      <p:sp>
+        <p:nvSpPr>
           <p:cNvPr id="16" name="Text 14"/>
           <p:cNvSpPr txBox="1"/>
           <p:nvPr/>
@@ -5707,7 +6195,7 @@
             <a:pPr algn="r"/>
             <a:fld id="{F7021451-1387-4CA6-816F-3879F97B5CBC}" type="slidenum">
               <a:rPr b="0" lang="en-US"/>
-              <a:t>6</a:t>
+              <a:t>7</a:t>
             </a:fld>
             <a:endParaRPr lang="en-US"/>
           </a:p>

</xml_diff>

<commit_message>
Lele on ADP now uses Tencent Hy3 for both thinking and replies; deck screenshot updated
</commit_message>
<xml_diff>
--- a/submission/architecture/laile-architecture.pptx
+++ b/submission/architecture/laile-architecture.pptx
@@ -113,12 +113,12 @@
   <p:extLst>
     <p:ext uri="{521415D9-36F7-43E2-AB2F-B90AF26B5E84}">
       <p14:sectionLst xmlns:p14="http://schemas.microsoft.com/office/powerpoint/2010/main">
-        <p14:section name="Overview" id="{26ef719b-610b-2fe8-267f-e4ff9f78ce21}">
+        <p14:section name="Overview" id="{cb69e534-36a7-cc58-8bd9-35b7e28641be}">
           <p14:sldIdLst>
             <p14:sldId id="256"/>
           </p14:sldIdLst>
         </p14:section>
-        <p14:section name="Architecture" id="{54467dff-0476-f395-72da-8707821fee14}">
+        <p14:section name="Architecture" id="{00ef2e97-86fe-4b63-90df-ad1737459a94}">
           <p14:sldIdLst>
             <p14:sldId id="257"/>
             <p14:sldId id="258"/>
@@ -126,7 +126,7 @@
             <p14:sldId id="260"/>
           </p14:sldIdLst>
         </p14:section>
-        <p14:section name="Build" id="{b3131de2-1aa4-2433-5b43-3d0acb3c3bd3}">
+        <p14:section name="Build" id="{2b281dcb-7294-4705-5164-aa32ef833158}">
           <p14:sldIdLst>
             <p14:sldId id="261"/>
             <p14:sldId id="262"/>
@@ -2165,7 +2165,7 @@
                   <a:schemeClr val="accent4"/>
                 </a:solidFill>
               </a:rPr>
-              <a:t>ADP: Lele's models, role prompt and welcome</a:t>
+              <a:t>ADP: Lele on Tencent Hy3, role prompt, welcome</a:t>
             </a:r>
             <a:endParaRPr lang="en-US" sz="1100" dirty="0"/>
           </a:p>

</xml_diff>

<commit_message>
Progress reads "Up 24°" and "Down 4/10", the check-in shows knee bend not the camera angle, and the check-in invite says "your"; 168 tests
</commit_message>
<xml_diff>
--- a/submission/architecture/laile-architecture.pptx
+++ b/submission/architecture/laile-architecture.pptx
@@ -113,12 +113,12 @@
   <p:extLst>
     <p:ext uri="{521415D9-36F7-43E2-AB2F-B90AF26B5E84}">
       <p14:sectionLst xmlns:p14="http://schemas.microsoft.com/office/powerpoint/2010/main">
-        <p14:section name="Overview" id="{cb69e534-36a7-cc58-8bd9-35b7e28641be}">
+        <p14:section name="Overview" id="{ffb0ec62-3a9f-4014-a8e5-95bb0743b60f}">
           <p14:sldIdLst>
             <p14:sldId id="256"/>
           </p14:sldIdLst>
         </p14:section>
-        <p14:section name="Architecture" id="{00ef2e97-86fe-4b63-90df-ad1737459a94}">
+        <p14:section name="Architecture" id="{3474f35c-82f6-104d-d8e0-776ef4781521}">
           <p14:sldIdLst>
             <p14:sldId id="257"/>
             <p14:sldId id="258"/>
@@ -126,7 +126,7 @@
             <p14:sldId id="260"/>
           </p14:sldIdLst>
         </p14:section>
-        <p14:section name="Build" id="{2b281dcb-7294-4705-5164-aa32ef833158}">
+        <p14:section name="Build" id="{a70f3625-a746-eae5-508d-d07077bbcd66}">
           <p14:sldIdLst>
             <p14:sldId id="261"/>
             <p14:sldId id="262"/>
@@ -5459,7 +5459,7 @@
                   <a:schemeClr val="tx1"/>
                 </a:solidFill>
               </a:rPr>
-              <a:t>166 automated tests: </a:t>
+              <a:t>168 automated tests: </a:t>
             </a:r>
             <a:pPr indent="0" marL="0">
               <a:spcAft>
@@ -5473,7 +5473,7 @@
                   <a:schemeClr val="tx1"/>
                 </a:solidFill>
               </a:rPr>
-              <a:t>127 core, 33 server, 6 web</a:t>
+              <a:t>129 core, 33 server, 6 web</a:t>
             </a:r>
             <a:endParaRPr lang="en-US" sz="1400" dirty="0"/>
           </a:p>

</xml_diff>